<commit_message>
sync docs/ from travplan@c43d1b0
</commit_message>
<xml_diff>
--- a/slides/study-controller/study-controller.pptx
+++ b/slides/study-controller/study-controller.pptx
@@ -546,7 +546,7 @@
           <a:lstStyle/>
           <a:p>
             <a:r>
-              <a:t>이 덱은 로봇 제어를 처음 공부하는 사람을 위한 개념 덱이다. 고전 피드백 제어에서 출발해 최적 제어, 표본 기반 MPC, 모델 오차를 다루는 법, 안전 필터까지 한 줄로 잇는다. 그림 대부분은 작은 시스템을 실제로 시뮬레이션해 그렸다. 논문 그림에는 출처를 달았다.</a:t>
+              <a:t>이 덱은 로봇 제어를 처음 공부하는 사람을 위한 개념 덱이다. 고전 피드백 제어에서 출발해 최적 제어, 샘플 기반 MPC, 모델 오차를 다루는 법, 안전 필터까지 한 줄로 잇는다. 그림 대부분은 작은 시스템을 실제로 시뮬레이션해 그렸다. 논문 그림에는 출처를 달았다.</a:t>
             </a:r>
           </a:p>
         </p:txBody>
@@ -616,7 +616,7 @@
           <a:lstStyle/>
           <a:p>
             <a:r>
-              <a:t>둘째 장은 모델을 쓰는 최적 제어다. 선형 모델과 이차 비용이면 LQR이 최적 이득을 닫힌 꼴로 준다. 제약이 있으면 매 주기 짧은 지평의 최적화를 다시 푸는 MPC를 쓴다. MPC는 로봇 제어에서 가장 넓게 쓰이는 틀이고, 다음 장의 MPPI도 MPC의 한 종류다.</a:t>
+              <a:t>둘째 장은 모델을 쓰는 최적 제어다. 선형 모델과 이차 비용이면 LQR이 최적 이득을 닫힌 꼴로 준다. 제약이 있으면 매 주기 짧은 horizon의 최적화를 다시 푸는 MPC를 쓴다. MPC는 로봇 제어에서 가장 넓게 쓰이는 틀이고, 다음 장의 MPPI도 MPC의 한 종류다.</a:t>
             </a:r>
           </a:p>
         </p:txBody>
@@ -686,7 +686,7 @@
           <a:lstStyle/>
           <a:p>
             <a:r>
-              <a:t>LQR은 상태 오차의 비용 Q와 입력의 비용 R을 맞바꾸는 문제다. 답은 놀랍게도 상태에 이득 행렬을 곱한 선형 되먹임이고, 그 이득은 이산 대수 Riccati 식으로 오프라인에 계산한다. 그래서 실행 비용이 거의 없다. Q와 R의 비율이 성격을 정한다. 그림처럼 R을 줄이면 입력을 아끼지 않고 빨리 수렴한다. 한계는 제약이다. 계산된 명령이 모터 한계를 넘으면 잘라 낼 수밖에 없고, 그러면 최적성이 깨진다. 이것이 MPC로 가는 이유다.</a:t>
+              <a:t>LQR은 상태 오차의 비용 Q와 입력의 비용 R을 맞바꾸는 문제다. 답은 놀랍게도 상태에 이득 행렬을 곱한 선형 피드백이고, 그 이득은 이산 대수 Riccati 식으로 오프라인에 계산한다. 그래서 실행 비용이 거의 없다. Q와 R의 비율이 성격을 정한다. 그림처럼 R을 줄이면 입력을 아끼지 않고 빨리 수렴한다. 한계는 제약이다. 계산된 명령이 모터 한계를 넘으면 잘라 낼 수밖에 없고, 그러면 최적성이 깨진다. 이것이 MPC로 가는 이유다.</a:t>
             </a:r>
           </a:p>
         </p:txBody>
@@ -756,7 +756,7 @@
           <a:lstStyle/>
           <a:p>
             <a:r>
-              <a:t>MPC는 지금 상태에서 N스텝 앞까지 모델로 예측하며, 비용을 최소화하고 제약을 지키는 명령열을 푼다. 그중 첫 명령만 실행하고, 다음 주기에 새 상태에서 다시 푼다. 이것이 이동 지평이다. 매번 다시 풀기 때문에 모델 오차나 외란이 있어도 되먹임이 된다. 지평 끝의 비용 V_f를 잘 고르면 짧은 지평으로도 긴 지평처럼 행동하며, 그림에서는 무한 지평 LQR의 가치를 썼다. 핵심 장점은 제약이다. 속도·가속·조향 한계를 최적화 문제 안에 바로 넣는다.</a:t>
+              <a:t>MPC는 지금 상태에서 N스텝 앞까지 모델로 예측하며, 비용을 최소화하고 제약을 지키는 명령열을 푼다. 그중 첫 명령만 실행하고, 다음 주기에 새 상태에서 다시 푼다. 이것이 receding horizon이다. 매번 다시 풀기 때문에 모델 오차나 외란이 있어도 피드백으로 보정된다. horizon 끝의 비용 V_f를 잘 고르면 짧은 horizon으로도 긴 horizon처럼 행동하며, 그림에서는 무한 horizon LQR의 가치를 썼다. 핵심 장점은 제약이다. 속도·가속·조향 한계를 최적화 문제 안에 바로 넣는다.</a:t>
             </a:r>
           </a:p>
         </p:txBody>
@@ -896,7 +896,7 @@
           <a:lstStyle/>
           <a:p>
             <a:r>
-              <a:t>MPC의 장점은 모두 모델과 최적화에서 나오고, 단점도 같은 곳에서 나온다. 특히 내비게이션에서는 장애물 비용이 칸마다 계단처럼 바뀌어 기울기가 거의 0이거나 정의되지 않는다. 기울기 기반 풀이기는 이런 비용에 약하다. 다음 장의 MPPI는 기울기 대신 많은 표본을 굴려 이 문제를 피한다.</a:t>
+              <a:t>MPC의 장점은 모두 모델과 최적화에서 나오고, 단점도 같은 곳에서 나온다. 특히 내비게이션에서는 장애물 비용이 셀마다 계단처럼 바뀌어 gradient가 거의 0이거나 정의되지 않는다. gradient 기반 솔버는 이런 비용에 약하다. 다음 장의 MPPI는 gradient 대신 많은 샘플을 rollout해 이 문제를 피한다.</a:t>
             </a:r>
           </a:p>
         </p:txBody>
@@ -966,7 +966,7 @@
           <a:lstStyle/>
           <a:p>
             <a:r>
-              <a:t>셋째 장은 MPPI다. 최적화 문제를 미분으로 풀지 않고, 잡음 섞은 명령열을 많이 굴려 비용의 지수 가중으로 평균한다. GPU로 병렬화하기 쉬워 오프로드 차량과 내비게이션에서 널리 쓰인다. 기본 식, 온도와 잡음의 모양, 계보, 학습 prior를 넣는 법, 그리고 기울기 기반 MPC와의 장단점을 본다.</a:t>
+              <a:t>셋째 장은 MPPI다. 최적화 문제를 미분으로 풀지 않고, 잡음을 섞은 명령열을 많이 rollout해 비용의 지수 가중으로 평균한다. GPU로 병렬화하기 쉬워 오프로드 차량과 내비게이션에서 널리 쓰인다. 기본 식, 온도와 잡음의 모양, 계보, 학습 prior를 넣는 법, 그리고 gradient 기반 MPC와의 장단점을 살펴본다.</a:t>
             </a:r>
           </a:p>
         </p:txBody>
@@ -1036,7 +1036,7 @@
           <a:lstStyle/>
           <a:p>
             <a:r>
-              <a:t>MPPI는 Model Predictive Path Integral의 줄임이다. 경로 적분 제어 이론에서 나왔고, 2017년판은 "비용의 볼츠만 분포에 KL로 가장 가까운 제어 분포"를 찾는 문제로 다시 유도했다. 계산은 단순하다. 현재 명령열 주변에 잡음을 섞은 후보를 많이 만들고, 모델로 굴려 비용을 매기고, 비용의 지수로 가중 평균한다. 비용을 미분하지 않으므로 충돌하면 큰 값, 아니면 0인 계단 비용도 그대로 쓴다. 강화학습 덱에서 본 최대 엔트로피 RL의 표본 판이기도 하다.</a:t>
+              <a:t>MPPI는 Model Predictive Path Integral의 줄임이다. 경로 적분 제어 이론에서 나왔고, 2017년판은 "비용의 볼츠만 분포에 KL로 가장 가까운 제어 분포"를 찾는 문제로 다시 유도했다. 계산은 단순하다. 현재 명령열 주변에 잡음을 섞은 후보를 많이 만들고, 모델로 rollout해 비용을 매기고, 비용의 지수로 가중 평균한다. 비용을 미분하지 않으므로 충돌하면 큰 값, 아니면 0인 계단 비용도 그대로 쓴다. 강화학습 덱에서 본 최대 엔트로피 RL의 샘플링 버전이기도 하다.</a:t>
             </a:r>
           </a:p>
         </p:txBody>
@@ -1106,7 +1106,7 @@
           <a:lstStyle/>
           <a:p>
             <a:r>
-              <a:t>온도는 MPPI에서 가장 중요한 손잡이다. 낮추면 탐욕적이 되고, 높이면 평균적이 된다. 실무에서는 유효 표본 수, 즉 가중치가 몇 개의 표본에 퍼져 있는지를 보고 조정한다. 비용 범위로 정규화하지 않는 구현에서는 비용 항을 하나 더하거나 가중치를 바꿀 때마다 사실상 온도도 바뀐다는 점을 기억해야 한다.</a:t>
+              <a:t>온도는 MPPI에서 가장 중요한 튜닝 파라미터다. 낮추면 탐욕적이 되고, 높이면 평균적이 된다. 실무에서는 유효 샘플 수, 즉 가중치가 몇 개의 샘플에 퍼져 있는지를 보고 조정한다. 비용 범위로 정규화하지 않는 구현에서는 비용 항을 하나 더하거나 가중치를 바꿀 때마다 사실상 온도도 바뀐다는 점을 기억해야 한다.</a:t>
             </a:r>
           </a:p>
         </p:txBody>
@@ -1176,7 +1176,7 @@
           <a:lstStyle/>
           <a:p>
             <a:r>
-              <a:t>MPPI의 해는 표본의 가중 평균이므로 표본의 모양을 닮는다. 스텝마다 독립인 잡음을 쓰면 평균한 명령도 떨리고, 떨림을 비용으로 벌하면 다른 목표와 싸운다. 잡음을 시간 상관 있게 뽑거나, 한 차수 높은 변화율 공간에서 뽑아 적분하면 처음부터 매끄러운 후보가 나온다. SMPPI는 이렇게 해서 MPPI의 유도를 그대로 지키면서 매끄러움을 얻었다.</a:t>
+              <a:t>MPPI의 해는 샘플의 가중 평균이므로 샘플의 모양을 닮는다. 스텝마다 독립인 잡음을 쓰면 평균한 명령도 떨리고, 떨림을 비용으로 페널티를 주면 다른 목표와 싸운다. 잡음을 시간 상관 있게 뽑거나, 한 차수 높은 변화율 공간에서 뽑아 적분하면 처음부터 매끄러운 후보가 나온다. SMPPI는 이렇게 해서 MPPI의 유도를 그대로 지키면서 매끄러움을 얻었다.</a:t>
             </a:r>
           </a:p>
         </p:txBody>
@@ -1246,7 +1246,7 @@
           <a:lstStyle/>
           <a:p>
             <a:r>
-              <a:t>계보를 보면 MPPI의 가중 평균 자체는 거의 그대로이고, 표본을 어디서 어떻게 뽑느냐와 구현이 바뀌었다. 강건 MPPI는 실제 상태가 위험할 때 명목 상태를 유지해 외란에 버틴다. MPPI-Generic은 같은 알고리즘도 구현에 따라 속도가 수십 배 다르다는 것을 보였다. 최근 연구는 MPPI의 해에 되먹임 이득을 붙여 주기 사이와 지연을 메우는 쪽으로 간다.</a:t>
+              <a:t>계보를 보면 MPPI의 가중 평균 자체는 거의 그대로이고, 샘플을 어디서 어떻게 뽑느냐와 구현이 바뀌었다. 강건 MPPI는 실제 상태가 위험할 때 명목 상태를 유지해 외란에 버틴다. MPPI-Generic은 같은 알고리즘도 구현에 따라 속도가 수십 배 다르다는 것을 보였다. 최근 연구는 MPPI의 해에 피드백 이득을 붙여 주기 사이와 지연을 메우는 쪽으로 간다.</a:t>
             </a:r>
           </a:p>
         </p:txBody>
@@ -1316,7 +1316,7 @@
           <a:lstStyle/>
           <a:p>
             <a:r>
-              <a:t>앞의 두 장은 제어 교과서의 내용이다. 3장부터는 로봇 내비게이션에서 많이 쓰는 표본 기반 MPC와, 실제 로봇에서 늘 부딪히는 모델 오차와 안전 문제로 넘어간다. 마지막 장은 복습용 표와 공부 순서다.</a:t>
+              <a:t>앞의 두 장은 제어 교과서의 내용이다. 3장부터는 로봇 내비게이션에서 많이 쓰는 샘플 기반 MPC와, 실제 로봇에서 늘 부딪히는 모델 오차와 안전 문제로 넘어간다. 마지막 장은 복습용 표와 공부 순서다.</a:t>
             </a:r>
           </a:p>
         </p:txBody>
@@ -1386,7 +1386,7 @@
           <a:lstStyle/>
           <a:p>
             <a:r>
-              <a:t>학습한 정책이나 Planner가 낸 명령열을 MPPI에 넣는 가장 쉬운 방법은 표본 분포의 평균을 그것으로 옮기는 것이다. 그런데 prior가 틀리면 매번 틀린 곳에서 다시 시작하게 된다. ProxPI는 prior를 "가까울수록 좋다"는 부드러운 비용으로만 넣는다. 그러면 장애물 비용 같은 다른 항이 prior와 다툴 수 있고, 최적화기의 보정이 반복마다 쌓인다. 실무에서는 일부 표본만 prior 근처에서 뽑는 혼합 방식도 쓴다.</a:t>
+              <a:t>학습한 정책이나 Planner가 낸 명령열을 MPPI에 넣는 가장 쉬운 방법은 샘플 분포의 평균을 그것으로 옮기는 것이다. 그런데 prior가 틀리면 매번 틀린 곳에서 다시 시작하게 된다. ProxPI는 prior를 "가까울수록 좋다"는 부드러운 비용으로만 넣는다. 그러면 장애물 비용 같은 다른 항이 prior와 다툴 수 있고, 최적화기의 보정이 반복마다 쌓인다. 실무에서는 일부 샘플만 prior 근처에서 뽑는 혼합 방식도 쓴다.</a:t>
             </a:r>
           </a:p>
         </p:txBody>
@@ -1456,7 +1456,7 @@
           <a:lstStyle/>
           <a:p>
             <a:r>
-              <a:t>두 방법은 강점이 갈린다. NMPC는 제약을 정확히 지키고 수렴이 빠르지만, 비용과 모델이 매끄러워야 한다. MPPI는 어떤 비용이든 쓸 수 있고 GPU로 병렬화하기 쉽지만, 제약은 벌점으로 근사하고 입력 차원이 커지면 표본이 부족해진다. 어느 쪽이 나은지는 문제에 따라 다르므로, 같은 조건에서 직접 비교하는 것이 좋다.</a:t>
+              <a:t>두 방법은 강점이 갈린다. NMPC는 제약을 정확히 지키고 수렴이 빠르지만, 비용과 모델이 매끄러워야 한다. MPPI는 어떤 비용이든 쓸 수 있고 GPU로 병렬화하기 쉽지만, 제약은 페널티로 근사하고 입력 차원이 커지면 샘플이 부족해진다. 어느 쪽이 나은지는 문제에 따라 다르므로, 같은 조건에서 직접 비교하는 것이 좋다.</a:t>
             </a:r>
           </a:p>
         </p:txBody>
@@ -1526,7 +1526,7 @@
           <a:lstStyle/>
           <a:p>
             <a:r>
-              <a:t>넷째 장은 모델 기반 제어의 가장 큰 약점, 모델 오차다. 먼저 가장 흔하고 가장 해로운 오차인 지연을 보고, 학습 동역학과 잔차 모델, 불확실성을 함께 내는 GP, 그리고 짧은 이력으로 숨은 조건을 추정하는 적응을 본다.</a:t>
+              <a:t>넷째 장은 모델 기반 제어의 가장 큰 약점, 모델 오차다. 먼저 가장 흔하고 가장 해로운 오차인 지연을 다루고, 학습 동역학과 잔차 모델, 불확실성을 함께 내는 GP, 그리고 짧은 이력으로 숨은 조건을 추정하는 적응을 살펴본다.</a:t>
             </a:r>
           </a:p>
         </p:txBody>
@@ -1596,7 +1596,7 @@
           <a:lstStyle/>
           <a:p>
             <a:r>
-              <a:t>지연은 제어에서 가장 흔하고 가장 해로운 모델 오차다. 지금 낸 명령이 나중에 걸리므로, 제어기는 이미 지나간 오차에 반응하게 된다. 이득을 낮추면 안정되지만 느려진다. 더 나은 방법은 지연을 모델에 넣는 것이다. 이미 보냈지만 아직 걸리지 않은 명령들로 지연 뒤의 상태를 예측하고, 그 상태를 기준으로 제어한다. Smith 예측기의 생각이며, MPC나 MPPI라면 rollout 모델에 지연을 넣으면 된다.</a:t>
+              <a:t>지연은 제어에서 가장 흔하고 가장 해로운 모델 오차다. 지금 낸 명령이 나중에 걸리므로, 제어기는 이미 지나간 오차에 반응하게 된다. 이득을 낮추면 안정되지만 느려진다. 더 나은 방법은 지연을 모델에 넣는 것이다. 이미 보냈지만 아직 걸리지 않은 명령들로 지연 뒤의 상태를 예측하고, 그 상태를 기준으로 제어한다. Smith predictor의 아이디어이며, MPC나 MPPI라면 rollout 모델에 지연을 넣으면 된다.</a:t>
             </a:r>
           </a:p>
         </p:txBody>
@@ -1666,7 +1666,7 @@
           <a:lstStyle/>
           <a:p>
             <a:r>
-              <a:t>표본 기반 MPC는 한 번 푸는 데 시간이 걸리고, 그동안 로봇은 계속 움직인다. 두 연구는 MPPI의 해에 되먹임 이득을 붙여 이 공백을 메운다. CLIS-MPPI는 계획 시작 상태를 확률 분포로 보고, 여러 시작점에서 굴린 rollout을 회귀해 이득을 얻는다. Feedback-MPPI는 미분으로 이득을 얻는다. 비용이 매끄럽지 않으면 미분 이득이 의미를 잃는다는 점이 선택 기준이다. CLIS-MPPI의 실물 시행은 5회뿐이라는 점도 함께 기억하자.</a:t>
+              <a:t>샘플 기반 MPC는 한 번 푸는 데 시간이 걸리고, 그동안 로봇은 계속 움직인다. 두 연구는 MPPI의 해에 피드백 이득을 붙여 이 공백을 메운다. CLIS-MPPI는 계획 시작 상태를 확률 분포로 보고, 여러 시작점에서 돌린 rollout을 회귀해 이득을 얻는다. Feedback-MPPI는 미분으로 이득을 얻는다. 비용이 매끄럽지 않으면 미분 이득이 의미를 잃는다는 점이 선택 기준이다. CLIS-MPPI의 실물 시행은 5회뿐이라는 점도 함께 기억해야 한다.</a:t>
             </a:r>
           </a:p>
         </p:txBody>
@@ -1736,7 +1736,7 @@
           <a:lstStyle/>
           <a:p>
             <a:r>
-              <a:t>MPC와 MPPI는 모델을 바꿔 끼울 수 있는 틀이다. 손으로 만든 운동학 모델이 슬립이나 지형 효과를 설명하지 못하면, 그 자리를 데이터로 배운 모델로 바꾼다. PETS는 앙상블로 불확실성을 함께 내고, IKD는 IMU로 지형 효과를 배우고, RMA는 숨은 환경 요인을 짧은 이력에서 추정한다. 학습 모델의 위험은 강화학습 덱에서 본 것과 같다. 계획기는 모델이 틀린 곳을 찾아가 이용한다.</a:t>
+              <a:t>MPC와 MPPI는 모델을 바꿔 끼울 수 있는 틀이다. 손으로 만든 운동학 모델이 슬립이나 지형 효과를 설명하지 못하면, 그 자리를 데이터로 배운 모델로 바꾼다. PETS는 앙상블로 불확실성을 함께 내고, IKD는 IMU로 지형 효과를 배우고, RMA는 숨은 환경 요인을 짧은 이력에서 추정한다. 학습 모델의 위험은 강화학습 덱에서 본 것과 같다. Planner는 모델이 틀린 곳을 찾아가 이용한다.</a:t>
             </a:r>
           </a:p>
         </p:txBody>
@@ -1806,7 +1806,7 @@
           <a:lstStyle/>
           <a:p>
             <a:r>
-              <a:t>세 연구 모두 큰 블랙박스 동역학을 처음부터 배우지 않는다. 물리 모델이 대부분을 설명하고 신경망은 잔차만 맡으니 작아도 되고 빠르고, 자료가 적어도 된다. 노면 마찰이나 하중처럼 보이지 않는 조건은 최근 몇 초의 상태·명령 이력을 요약한 문맥 벡터로 나른다. 배포 중에 신경망 가중치를 바꾸지 않고도 조건에 적응하는 셈이다.</a:t>
+              <a:t>세 연구 모두 큰 블랙박스 동역학을 처음부터 배우지 않는다. 물리 모델이 대부분을 설명하고 신경망은 잔차만 맡으니 작아도 되고 빠르고, 데이터가 적어도 된다. 노면 마찰이나 하중처럼 보이지 않는 조건은 최근 몇 초의 상태·명령 이력을 요약한 context 벡터로 전달한다. 배포 중에 신경망 가중치를 바꾸지 않고도 조건에 적응하는 셈이다.</a:t>
             </a:r>
           </a:p>
         </p:txBody>
@@ -1876,7 +1876,7 @@
           <a:lstStyle/>
           <a:p>
             <a:r>
-              <a:t>가우시안 과정은 함수 위의 확률 분포다. 커널이 "가까운 입력은 비슷한 출력"을 정하고, 관측을 조건으로 하면 평균과 분산이 닫힌 꼴로 나온다. 제어에서 GP의 진짜 가치는 분산이다. 모델을 얼마나 모르는지를 알면 그만큼 제약을 조이거나 속도를 줄일 수 있다. 다만 바퀴 로봇의 잔차는 상당 부분이 지연처럼 선형이라, 실측 연구에서는 선형 베이즈 회귀가 GP만큼 또는 더 정확했다. 비선형이 남는 채널과 분산이 필요한 곳에만 GP를 쓰는 것이 실용적이다.</a:t>
+              <a:t>가우시안 프로세스는 함수 위의 확률 분포다. 커널이 "가까운 입력은 비슷한 출력"을 정하고, 관측을 조건으로 하면 평균과 분산이 닫힌 꼴로 나온다. 제어에서 GP의 진짜 가치는 분산이다. 모델을 얼마나 모르는지를 알면 그만큼 제약을 조이거나 속도를 줄일 수 있다. 다만 바퀴 로봇의 잔차는 상당 부분이 지연처럼 선형이라, 실측 연구에서는 선형 베이즈 회귀가 GP만큼 또는 더 정확했다. 비선형이 남는 채널과 분산이 필요한 곳에만 GP를 쓰는 것이 실용적이다.</a:t>
             </a:r>
           </a:p>
         </p:txBody>
@@ -1946,7 +1946,7 @@
           <a:lstStyle/>
           <a:p>
             <a:r>
-              <a:t>마찰, 하중, 노면처럼 센서로 직접 보이지 않는 조건을 다루는 세 방식이다. RMA는 시뮬레이션에서 정답 조건을 아는 교사를 학습한 뒤, 학생이 최근 이력만 보고 그 잠재를 맞히게 한다. 온라인 회귀는 모델의 몇 계수만 실시간으로 고친다. 메타학습은 몇 스텝의 갱신만으로 새 조건에 맞도록 시작점을 배운다. 공통의 위험은 학습 때 보지 못한 조건이다.</a:t>
+              <a:t>마찰, 하중, 노면처럼 센서로 직접 보이지 않는 조건을 다루는 세 방식이다. RMA는 시뮬레이션에서 정답 조건을 아는 teacher를 학습한 뒤, student가 최근 이력만 보고 그 latent를 맞히게 한다. 온라인 회귀는 모델의 몇 계수만 실시간으로 고친다. 메타학습은 몇 스텝의 갱신만으로 새 조건에 맞도록 시작점을 배운다. 공통의 위험은 학습 때 보지 못한 조건이다.</a:t>
             </a:r>
           </a:p>
         </p:txBody>
@@ -2016,7 +2016,7 @@
           <a:lstStyle/>
           <a:p>
             <a:r>
-              <a:t>아래로 갈수록 표현력이 커지고 자료와 위험도 커진다. 가장 먼저 할 일은 지연처럼 큰 오차를 물리 모델에 넣는 것이다. 그것만으로 해결되는 경우가 많다. 그래도 남는 오차는 작은 잔차로 배우고, 가능하면 불확실성을 함께 내서 제어기가 모르는 곳에서 조심하게 한다.</a:t>
+              <a:t>아래로 갈수록 표현력이 커지고 데이터와 위험도 커진다. 가장 먼저 할 일은 지연처럼 큰 오차를 물리 모델에 넣는 것이다. 그것만으로 해결되는 경우가 많다. 그래도 남는 오차는 작은 잔차로 배우고, 가능하면 불확실성을 함께 내서 제어기가 모르는 곳에서 조심하게 한다.</a:t>
             </a:r>
           </a:p>
         </p:txBody>
@@ -2086,7 +2086,7 @@
           <a:lstStyle/>
           <a:p>
             <a:r>
-              <a:t>세 번째 덱이다. 계획 덱의 경로를 받아, 모델이 틀리고 명령이 늦게 닿는 실제 상황에서 따라가는 법을 본다. 인식 덱의 분산과 사람 추적은 5장의 안전에서 쓰인다. 2장의 MPC는 다음 덱인 비선형 MPC에서 문제 세우기와 실시간 풀이까지 깊게 판다. MPPI의 식은 강화학습 덱의 추론으로서의 제어와 같아서, 두 덱을 오가며 보면 서로 이해가 깊어진다. 일곱 덱 전체의 순서와 10주 계획은 로드맵 덱에 있다.</a:t>
+              <a:t>세 번째 덱이다. 계획 덱의 경로를 받아, 모델이 틀리고 명령이 늦게 닿는 실제 상황에서 따라가는 법을 다룬다. 인식 덱의 분산과 사람 추적은 5장의 안전에서 쓰인다. 2장의 MPC는 다음 덱인 비선형 MPC에서 문제 세우기와 실시간 풀이까지 깊게 판다. MPPI의 식은 강화학습 덱의 control as inference와 같아서, 두 덱을 오가며 보면 서로 이해가 깊어진다. 일곱 덱 전체의 순서와 10주 계획은 로드맵 덱에 있다.</a:t>
             </a:r>
           </a:p>
         </p:txBody>
@@ -2156,7 +2156,7 @@
           <a:lstStyle/>
           <a:p>
             <a:r>
-              <a:t>다섯째 장은 안전이다. 동적 장애물을 다루는 두 구조, 즉 비용 통합형과 외부 안전 필터형을 비교한다. 외부 필터의 대표인 제어 장벽 함수(CBF), 평균 대신 꼬리를 보는 CVaR, 확률 제약이 기대는 불확실성이 맞는지 재는 보정, 그리고 많은 장애물을 합치는 법과 표본으로 만드는 안전 필터를 본다.</a:t>
+              <a:t>다섯째 장은 안전이다. 동적 장애물을 다루는 두 구조, 즉 비용 통합형과 외부 안전 필터형을 비교한다. 외부 필터의 대표인 제어 장벽 함수(CBF), 평균 대신 꼬리를 보는 CVaR, 확률 제약이 기대는 불확실성이 맞는지 재는 보정, 그리고 많은 장애물을 합치는 법과 샘플로 만드는 안전 필터를 살펴본다.</a:t>
             </a:r>
           </a:p>
         </p:txBody>
@@ -2226,7 +2226,7 @@
           <a:lstStyle/>
           <a:p>
             <a:r>
-              <a:t>비용 통합형은 장애물을 비용으로 표현해 최적화에 맡긴다. 표본 기반 MPC와 잘 맞고 지연이 없지만, 다른 비용 항과 맞바꿔지므로 반드시 피한다는 보장은 없다. 외부 안전 필터는 제어기의 출력을 받아, 안전 조건을 만족하는 가장 가까운 명령으로 투영한다. 제어기가 무엇이든 같은 보장을 준다. 오른쪽 그림의 OcclusionCBF는 가려진 사각지대에서 사람이 튀어나올 수 있는 영역까지 고려해 보이기 전에 감속한다.</a:t>
+              <a:t>비용 통합형은 장애물을 비용으로 표현해 최적화에 맡긴다. 샘플 기반 MPC와 잘 맞고 지연이 없지만, 다른 비용 항과 맞바꿔지므로 반드시 피한다는 보장은 없다. 외부 안전 필터는 제어기의 출력을 받아, 안전 조건을 만족하는 가장 가까운 명령으로 투영한다. 제어기가 무엇이든 같은 보장을 준다. 오른쪽 그림의 OcclusionCBF는 가려진 사각지대에서 사람이 튀어나올 수 있는 영역까지 고려해 보이기 전에 감속한다.</a:t>
             </a:r>
           </a:p>
         </p:txBody>
@@ -2366,7 +2366,7 @@
           <a:lstStyle/>
           <a:p>
             <a:r>
-              <a:t>위험 척도는 비용 분포의 어디를 볼지 정한다. 평균은 대부분 좋고 가끔 크게 나쁜 정책을 구별하지 못한다. 최악의 경우만 보면 너무 보수적이 된다. CVaR는 그 사이로, 나쁜 쪽 일부의 평균을 본다. 오른쪽 식처럼 보조 변수 하나로 볼록 최적화가 되므로 MPC나 MPPI의 비용에 넣기 쉽다. MPPI에서는 표본들의 비용 분포에서 바로 꼬리 평균을 계산할 수 있다.</a:t>
+              <a:t>위험 척도는 비용 분포의 어디를 볼지 정한다. 평균은 대부분 좋고 가끔 크게 나쁜 정책을 구별하지 못한다. 최악의 경우만 보면 너무 보수적이 된다. CVaR는 그 사이로, 나쁜 쪽 일부의 평균을 본다. 오른쪽 식처럼 보조 변수 하나로 볼록 최적화가 되므로 MPC나 MPPI의 비용에 넣기 쉽다. MPPI에서는 샘플들의 비용 분포에서 바로 꼬리 평균을 계산할 수 있다.</a:t>
             </a:r>
           </a:p>
         </p:txBody>
@@ -2436,7 +2436,7 @@
           <a:lstStyle/>
           <a:p>
             <a:r>
-              <a:t>확률 제약은 "충돌 확률이 δ 이하"를 지키려 한다. 그런데 그 확률은 예측기나 지도가 낸 불확실성으로 계산하므로, 불확실성이 틀리면 보장도 틀린다. 과신하면 위험을 과소평가하고, 과소신하면 위험이 넓게 퍼져 오히려 덜 조심하거나 멈춘다. 그래서 먼저 보정을 잰다. 예측한 σ 구간 안에 실제 값이 명목 비율만큼 드는지 보는 것이다. conformal prediction은 보정 자료의 오차 순위만으로 포함률을 보장하는 구간을 만드는 간단한 방법이다.</a:t>
+              <a:t>확률 제약은 "충돌 확률이 δ 이하"를 지키려 한다. 그런데 그 확률은 예측기나 지도가 낸 불확실성으로 계산하므로, 불확실성이 틀리면 보장도 틀린다. 과신하면 위험을 과소평가하고, 불확실성을 실제보다 크게 잡으면 위험이 넓게 퍼져 오히려 덜 조심하거나 멈춘다. 그래서 먼저 보정을 잰다. 예측한 σ 구간 안에 실제 값이 명목 비율만큼 드는지 보는 것이다. conformal prediction은 보정 데이터의 오차 순위만으로 포함률을 보장하는 구간을 만드는 간단한 방법이다.</a:t>
             </a:r>
           </a:p>
         </p:txBody>
@@ -2506,7 +2506,7 @@
           <a:lstStyle/>
           <a:p>
             <a:r>
-              <a:t>장애물이 여러 개면 barrier도 여러 개다. 미분 가능하게 합치려고 soft-min을 쓰면, 그 값이 늘 실제 최솟값보다 작아서 안전 집합이 깎인다. 장애물이 많을수록 깎이는 몫이 커져 좁은 통로가 먼저 닫힌다. 정확한 최솟값을 쓰면 틈을 지키지만 계산이 무겁다. Poisson 안전 함수는 지도 전체에서 경계 조건을 만족하는 매끄러운 함수 하나를 풀어 이 문제를 피한다. 다만 실물 실험에서 보행 제어기의 속도 추종 지연 때문에 h가 잠깐 음수가 됐다고 보고했다. 지연은 안전 필터에서도 문제다.</a:t>
+              <a:t>장애물이 여러 개면 barrier도 여러 개다. 미분 가능하게 합치려고 soft-min을 쓰면, 그 값이 늘 실제 최솟값보다 작아서 안전 집합이 깎인다. 장애물이 많을수록 깎이는 양이 커져 좁은 통로가 먼저 닫힌다. 정확한 최솟값을 쓰면 틈을 지키지만 계산이 무겁다. Poisson 안전 함수는 지도 전체에서 경계 조건을 만족하는 매끄러운 함수 하나를 풀어 이 문제를 피한다. 다만 실물 실험에서 보행 제어기의 속도 추종 지연 때문에 h가 잠깐 음수가 됐다고 보고했다. 지연은 안전 필터에서도 문제다.</a:t>
             </a:r>
           </a:p>
         </p:txBody>
@@ -2576,7 +2576,7 @@
           <a:lstStyle/>
           <a:p>
             <a:r>
-              <a:t>예측 안전 필터의 생각은 이렇다. 지금 명령을 실행해도 그 뒤에 안전하게 멈출 수 있는 길이 하나라도 있으면 허용하고, 없으면 미리 저장해 둔 안전한 백업으로 바꾼다. 이 연구는 그 "길이 있나"를 표본으로 확인한다. 표본 기반 MPC는 이미 많은 rollout을 굴리므로 같은 감시기를 거의 공짜로 만들 수 있다. 다만 rollout이 정지로 끝나도록 제동 꼬리를 붙여야 하고, 지연이 있으면 제동 거리가 늘어난다는 점을 반영해야 한다.</a:t>
+              <a:t>예측 안전 필터의 아이디어는 이렇다. 지금 명령을 실행해도 그 뒤에 안전하게 멈출 수 있는 길이 하나라도 있으면 허용하고, 없으면 미리 저장해 둔 안전한 백업으로 바꾼다. 이 연구는 그 "길이 있나"를 샘플로 확인한다. 샘플 기반 MPC는 이미 많은 rollout을 돌리므로 같은 감시기를 거의 공짜로 만들 수 있다. 다만 rollout 끝에 정지까지 제동하는 구간을 붙여야 하고, 지연이 있으면 제동 거리가 늘어난다는 점을 반영해야 한다.</a:t>
             </a:r>
           </a:p>
         </p:txBody>
@@ -2646,7 +2646,7 @@
           <a:lstStyle/>
           <a:p>
             <a:r>
-              <a:t>표의 수치는 각 논문이 보고한 계산 시간이다. 하드웨어가 다르니 대략의 크기로만 보자. 안전 방식은 셋을 맞바꾼다. 계산 지연, 보장의 강도, 그리고 의존성과 가정이다. 강한 보장일수록 모델과 계산이 많이 들고 보수적이 된다. 그래서 대부분의 시스템은 가벼운 비용 기반 회피로 일상을 처리하고, 드문 위험 순간에만 개입하는 가벼운 필터를 마지막에 둔다.</a:t>
+              <a:t>표의 수치는 각 논문이 보고한 계산 시간이다. 하드웨어가 다르니 대략의 크기로만 봐야 한다. 안전 방식은 셋을 맞바꾼다. 계산 지연, 보장의 강도, 그리고 의존성과 가정이다. 강한 보장일수록 모델과 계산이 많이 들고 보수적이 된다. 그래서 대부분의 시스템은 가벼운 비용 기반 회피로 일상을 처리하고, 드문 위험 순간에만 개입하는 가벼운 필터를 마지막에 둔다.</a:t>
             </a:r>
           </a:p>
         </p:txBody>
@@ -2856,7 +2856,7 @@
           <a:lstStyle/>
           <a:p>
             <a:r>
-              <a:t>제어의 출발점은 모델이다. 로봇이 명령을 받으면 어떻게 움직이는지를 상태공간 모델로 적는다. 되먹임은 그 모델이 완벽하지 않다는 것을 인정하는 장치다. 안정성은 되먹임이 오히려 해가 되지 않는지를 묻는다. 그리고 디지털 제어기는 주기마다 한 번 계산하므로 연속 시간 이론과 달리 계산·통신 지연이 생긴다. 이 네 가지가 이후 모든 장에 나온다.</a:t>
+              <a:t>제어의 출발점은 모델이다. 로봇이 명령을 받으면 어떻게 움직이는지를 상태공간 모델로 적는다. 피드백은 그 모델이 완벽하지 않다는 것을 인정하는 장치다. 안정성은 피드백이 오히려 해가 되지 않는지를 묻는다. 그리고 디지털 제어기는 주기마다 한 번 계산하므로 연속 시간 이론과 달리 계산·통신 지연이 생긴다. 이 네 가지가 이후 모든 장에 나온다.</a:t>
             </a:r>
           </a:p>
         </p:txBody>
@@ -2996,7 +2996,7 @@
           <a:lstStyle/>
           <a:p>
             <a:r>
-              <a:t>실제 로봇에서 제어가 이상할 때 원인의 대부분은 알고리즘이 아니라 이런 기본 항목이다. 특히 지연은 시뮬레이션에서 빠뜨리기 쉬워 시뮬과 실물의 차이를 가장 크게 만든다. 계산 시간도 평균이 아니라 최댓값이 중요하다. 한 주기라도 늦으면 그 순간 제어가 비기 때문이다.</a:t>
+              <a:t>실제 로봇에서 제어가 이상할 때 원인의 대부분은 알고리즘이 아니라 이런 기본 항목이다. 특히 지연은 시뮬레이션에서 빠뜨리기 쉬워 시뮬과 실물의 차이를 가장 크게 만든다. 계산 시간도 평균이 아니라 최댓값이 중요하다. 한 주기라도 늦으면 그 순간 제어가 끊기기 때문이다.</a:t>
             </a:r>
           </a:p>
         </p:txBody>
@@ -3066,7 +3066,7 @@
           <a:lstStyle/>
           <a:p>
             <a:r>
-              <a:t>순서는 고전 제어, 최적 제어와 MPC, 그리고 로봇 응용이다. 첫 책은 되먹임과 안정성의 직관을, 둘째 책은 MPC의 이론을 준다. 그리고 가장 확실한 공부는 구현이다. 이 덱의 그림처럼 작은 시스템을 수십 줄로 시뮬레이션해 보면, 이득과 지연과 제약이 무엇을 하는지 손에 잡힌다.</a:t>
+              <a:t>순서는 고전 제어, 최적 제어와 MPC, 그리고 로봇 응용이다. 첫 책은 피드백과 안정성의 직관을, 둘째 책은 MPC의 이론을 준다. 그리고 가장 확실한 공부는 구현이다. 이 덱의 그림처럼 작은 시스템을 수십 줄로 시뮬레이션해 보면, 이득과 지연과 제약이 무엇을 하는지 손에 잡힌다.</a:t>
             </a:r>
           </a:p>
         </p:txBody>
@@ -3416,7 +3416,7 @@
           <a:lstStyle/>
           <a:p>
             <a:r>
-              <a:t>첫째 장은 모델을 거의 쓰지 않는 고전 제어다. 산업 현장 제어기의 대부분을 차지하는 PID와, 바퀴 로봇의 경로 추종에 가장 많이 쓰는 pure pursuit를 본다. 단순하지만 지금도 많은 로봇이 이것으로 움직인다.</a:t>
+              <a:t>첫째 장은 모델을 거의 쓰지 않는 고전 제어다. 산업 현장 제어기의 대부분을 차지하는 PID와, 바퀴 로봇의 경로 추종에 가장 많이 쓰는 pure pursuit를 다룬다. 단순하지만 지금도 많은 로봇이 이것으로 움직인다.</a:t>
             </a:r>
           </a:p>
         </p:txBody>
@@ -3486,7 +3486,7 @@
           <a:lstStyle/>
           <a:p>
             <a:r>
-              <a:t>PID는 오차의 현재, 과거, 미래 경향을 각각 비례, 적분, 미분으로 본다. P만 쓰면 이득을 키울수록 빠르지만 출렁이고, 경사 같은 일정한 외란 앞에서는 오차가 남는다. I는 오차를 시간에 걸쳐 더하므로 남은 오차가 0이 될 때까지 명령을 키운다. 대신 모터가 포화되면 적분이 계속 쌓이는 windup이 생겨 클램핑 같은 대책이 필요하다. D는 오차가 줄어드는 속도에 반대로 작용해 제동을 건다. 여기서는 목표가 계단으로 바뀔 때 미분이 튀지 않도록 측정값의 미분을 썼다.</a:t>
+              <a:t>PID는 오차의 현재, 과거, 미래 경향을 각각 비례, 적분, 미분으로 본다. P만 쓰면 이득을 키울수록 빠르지만 출렁이고, 경사 같은 일정한 외란 앞에서는 오차가 남는다. I는 오차를 시간에 걸쳐 더하므로 남은 오차가 0이 될 때까지 명령을 키운다. 대신 모터가 포화되면 적분이 계속 쌓이는 windup이 생겨 클램핑 같은 대책이 필요하다. D는 오차의 변화율에 반대로 작용해 감쇠를 준다. 여기서는 목표가 계단으로 바뀔 때 미분이 튀지 않도록 측정값의 미분을 썼다.</a:t>
             </a:r>
           </a:p>
         </p:txBody>
@@ -3556,7 +3556,7 @@
           <a:lstStyle/>
           <a:p>
             <a:r>
-              <a:t>pure pursuit는 사람이 운전할 때 앞을 보는 것과 닮았다. 경로 위에서 로봇으로부터 L_d만큼 떨어진 점을 고르고, 지금 방향을 접선으로 하면서 그 점을 지나는 원을 그린다. 그 원의 곡률이 곧 조향 명령이다. L_d가 짧으면 경로에 바짝 붙지만 출렁이기 쉽고, 길면 매끄럽지만 모서리를 크게 깎는다. 경로를 따라갈 뿐 장애물이나 속도 한계는 모르므로, 회피는 위층 Planner나 MPC에 맡긴다.</a:t>
+              <a:t>pure pursuit는 사람이 운전할 때 앞을 보는 것과 닮았다. 경로 위에서 로봇으로부터 L_d만큼 떨어진 점을 고르고, 지금 방향을 접선으로 하면서 그 점을 지나는 원을 그린다. 그 원의 곡률이 곧 조향 명령이다. L_d가 짧으면 경로에 바짝 붙지만 출렁이기 쉽고, 길면 매끄럽지만 모서리를 크게 깎는다. 경로를 따라갈 뿐 장애물이나 속도 한계는 모르므로, 회피는 상위 Planner나 MPC에 맡긴다.</a:t>
             </a:r>
           </a:p>
         </p:txBody>
@@ -3626,7 +3626,7 @@
           <a:lstStyle/>
           <a:p>
             <a:r>
-              <a:t>고전 추종기는 지금 오차만 보고 반응한다. 그래서 단순하고 튼튼하지만, 곧 다가올 급커브나 속도 한계, 장애물을 미리 반영하지 못한다. 다음 장의 LQR은 모델을 써서 여러 상태를 한꺼번에 최적으로 되먹이고, MPC는 미래를 예측해 제약까지 지킨다. 대가는 모델의 정확도와 계산량이다.</a:t>
+              <a:t>고전 추종기는 지금 오차만 보고 반응한다. 그래서 단순하고 강건하지만, 곧 다가올 급커브나 속도 한계, 장애물을 미리 반영하지 못한다. 다음 장의 LQR은 모델을 써서 여러 상태를 한꺼번에 최적으로 피드백하고, MPC는 미래를 예측해 제약까지 지킨다. 대가는 모델의 정확도와 계산량이다.</a:t>
             </a:r>
           </a:p>
         </p:txBody>
@@ -6776,7 +6776,7 @@
                 <a:ea typeface="Malgun Gothic"/>
                 <a:cs typeface="Malgun Gothic"/>
               </a:rPr>
-              <a:t>PID와 경로 추종에서 LQR·MPC, 표본 기반 MPPI, 모델 오차와 적응, 안전 필터까지 — 그림과 배경지식과 장단점으로 보는 제어</a:t>
+              <a:t>PID와 경로 추종에서 LQR·MPC, 샘플 기반 MPPI, 모델 오차와 적응, 안전 필터까지 — 그림과 배경지식과 장단점으로 보는 제어</a:t>
             </a:r>
           </a:p>
         </p:txBody>
@@ -7244,7 +7244,7 @@
                 <a:ea typeface="Malgun Gothic"/>
                 <a:cs typeface="Malgun Gothic"/>
               </a:rPr>
-              <a:t>모델로 미래를 굴려 보고</a:t>
+              <a:t>모델로 미래를 시뮬레이션해 보고</a:t>
             </a:r>
           </a:p>
           <a:p>
@@ -7411,7 +7411,7 @@
                 <a:ea typeface="Malgun Gothic"/>
                 <a:cs typeface="Malgun Gothic"/>
               </a:rPr>
-              <a:t>선형 모델과 이차 비용이면 최적 제어는 상태의 선형 되먹임이다</a:t>
+              <a:t>선형 모델과 이차 비용이면 최적 제어는 상태의 선형 피드백이다</a:t>
             </a:r>
           </a:p>
         </p:txBody>
@@ -8411,7 +8411,7 @@
                 <a:ea typeface="Malgun Gothic"/>
                 <a:cs typeface="Malgun Gothic"/>
               </a:rPr>
-              <a:t>이동 지평(receding horizon). 점선은 각 시각에 세운 3초 예측, 회색 띠는 실제로 실행된 궤적. 외란으로 어긋나도 다시 풀 때 바로잡는다</a:t>
+              <a:t>receding horizon. 점선은 각 시각에 세운 3초 예측, 회색 띠는 실제로 실행된 궤적. 외란으로 어긋나도 다시 풀 때 바로잡는다</a:t>
             </a:r>
           </a:p>
         </p:txBody>
@@ -8519,7 +8519,7 @@
                 <a:ea typeface="Malgun Gothic"/>
                 <a:cs typeface="Malgun Gothic"/>
               </a:rPr>
-              <a:t>모델과 제약의 꼴이 풀이기를 정한다</a:t>
+              <a:t>모델과 제약의 꼴이 솔버를 정한다</a:t>
             </a:r>
           </a:p>
         </p:txBody>
@@ -8905,7 +8905,7 @@
                           <a:ea typeface="Malgun Gothic"/>
                           <a:cs typeface="Malgun Gothic"/>
                         </a:rPr>
-                        <a:t>명목 MPC + 보조 되먹임</a:t>
+                        <a:t>명목 MPC + 보조 피드백</a:t>
                       </a:r>
                     </a:p>
                   </a:txBody>
@@ -9064,7 +9064,7 @@
                           <a:ea typeface="Malgun Gothic"/>
                           <a:cs typeface="Malgun Gothic"/>
                         </a:rPr>
-                        <a:t>표본 기반(MPPI, CEM)</a:t>
+                        <a:t>샘플 기반(MPPI, CEM)</a:t>
                       </a:r>
                     </a:p>
                   </a:txBody>
@@ -9112,7 +9112,7 @@
                           <a:ea typeface="Malgun Gothic"/>
                           <a:cs typeface="Malgun Gothic"/>
                         </a:rPr>
-                        <a:t>표본을 굴려 가중 평균</a:t>
+                        <a:t>샘플을 rollout해 가중 평균</a:t>
                       </a:r>
                     </a:p>
                   </a:txBody>
@@ -9670,7 +9670,7 @@
                 <a:ea typeface="Malgun Gothic"/>
                 <a:cs typeface="Malgun Gothic"/>
               </a:rPr>
-              <a:t>어기면 큰 벌점. 늘 해가 있지만 위반이 가능하다.</a:t>
+              <a:t>어기면 큰 페널티. 늘 해가 있지만 위반이 가능하다.</a:t>
             </a:r>
           </a:p>
         </p:txBody>
@@ -10171,7 +10171,7 @@
                 <a:ea typeface="Malgun Gothic"/>
                 <a:cs typeface="Malgun Gothic"/>
               </a:rPr>
-              <a:t>이동 지평이라 모델 오차에 되먹임이 된다</a:t>
+              <a:t>receding horizon이라 모델 오차가 피드백으로 보정된다</a:t>
             </a:r>
           </a:p>
         </p:txBody>
@@ -10521,7 +10521,7 @@
                 <a:ea typeface="Malgun Gothic"/>
                 <a:cs typeface="Malgun Gothic"/>
               </a:rPr>
-              <a:t>장애물처럼 비매끄러운 비용은 기울기가 없다</a:t>
+              <a:t>장애물처럼 non-smooth 비용은 gradient가 없다</a:t>
             </a:r>
           </a:p>
         </p:txBody>
@@ -10564,7 +10564,7 @@
                 <a:ea typeface="Malgun Gothic"/>
                 <a:cs typeface="Malgun Gothic"/>
               </a:rPr>
-              <a:t>튜닝 항목(지평, 가중치, 제약)이 많다</a:t>
+              <a:t>튜닝 항목(horizon, 가중치, 제약)이 많다</a:t>
             </a:r>
           </a:p>
         </p:txBody>
@@ -10647,7 +10647,7 @@
                 <a:ea typeface="Malgun Gothic"/>
                 <a:cs typeface="Malgun Gothic"/>
               </a:rPr>
-              <a:t> 비용이 매끄럽지 않고 기울기가 없을 때는 표본을 굴리는 MPPI가 대안이 된다.</a:t>
+              <a:t> 비용이 매끄럽지 않고 gradient가 없을 때는 샘플을 rollout하는 MPPI가 대안이 된다.</a:t>
             </a:r>
           </a:p>
         </p:txBody>
@@ -10714,7 +10714,7 @@
                 <a:ea typeface="Malgun Gothic"/>
                 <a:cs typeface="Malgun Gothic"/>
               </a:rPr>
-              <a:t>3 · 표본 기반 MPC: MPPI</a:t>
+              <a:t>3 · 샘플 기반 MPC: MPPI</a:t>
             </a:r>
           </a:p>
         </p:txBody>
@@ -10755,7 +10755,7 @@
                 <a:ea typeface="Malgun Gothic"/>
                 <a:cs typeface="Malgun Gothic"/>
               </a:rPr>
-              <a:t>명령열을 수백 개 굴려 보고</a:t>
+              <a:t>명령열을 수백 개 rollout해 보고</a:t>
             </a:r>
           </a:p>
           <a:p>
@@ -10773,7 +10773,7 @@
                 <a:ea typeface="Malgun Gothic"/>
                 <a:cs typeface="Malgun Gothic"/>
               </a:rPr>
-              <a:t>비용이 낮을수록 큰 표를 준다</a:t>
+              <a:t>비용이 낮을수록 큰 가중치를 준다</a:t>
             </a:r>
           </a:p>
         </p:txBody>
@@ -10814,7 +10814,7 @@
                 <a:ea typeface="Malgun Gothic"/>
                 <a:cs typeface="Malgun Gothic"/>
               </a:rPr>
-              <a:t>기울기가 필요 없어 장애물처럼 계단 같은 비용도 그대로 쓴다.</a:t>
+              <a:t>gradient가 필요 없어 장애물처럼 계단 같은 비용도 그대로 쓴다.</a:t>
             </a:r>
           </a:p>
         </p:txBody>
@@ -10922,7 +10922,7 @@
                 <a:ea typeface="Malgun Gothic"/>
                 <a:cs typeface="Malgun Gothic"/>
               </a:rPr>
-              <a:t>비용이 낮은 rollout일수록 지수적으로 큰 표를 받는다</a:t>
+              <a:t>비용이 낮은 rollout일수록 지수적으로 큰 가중치를 받는다</a:t>
             </a:r>
           </a:p>
         </p:txBody>
@@ -11196,7 +11196,7 @@
                 <a:ea typeface="Malgun Gothic"/>
                 <a:cs typeface="Malgun Gothic"/>
               </a:rPr>
-              <a:t>① 흔들기</a:t>
+              <a:t>① 섭동</a:t>
             </a:r>
           </a:p>
         </p:txBody>
@@ -11488,7 +11488,7 @@
                 <a:ea typeface="Malgun Gothic"/>
                 <a:cs typeface="Malgun Gothic"/>
               </a:rPr>
-              <a:t>② 굴리기</a:t>
+              <a:t>② rollout</a:t>
             </a:r>
           </a:p>
         </p:txBody>
@@ -11529,7 +11529,7 @@
                 <a:ea typeface="Malgun Gothic"/>
                 <a:cs typeface="Malgun Gothic"/>
               </a:rPr>
-              <a:t>모델로 지평 끝까지, 비용 </a:t>
+              <a:t>모델로 horizon 끝까지, 비용 </a:t>
             </a:r>
             <a:r>
               <a:rPr sz="1050" b="0" i="1">
@@ -11769,7 +11769,7 @@
                 <a:ea typeface="Malgun Gothic"/>
                 <a:cs typeface="Malgun Gothic"/>
               </a:rPr>
-              <a:t>③ 평균</a:t>
+              <a:t>③ 가중 평균</a:t>
             </a:r>
           </a:p>
         </p:txBody>
@@ -11864,7 +11864,7 @@
                 <a:ea typeface="Malgun Gothic"/>
                 <a:cs typeface="Malgun Gothic"/>
               </a:rPr>
-              <a:t>K는 보통 수백–수천, GPU에서 한꺼번에 굴린다</a:t>
+              <a:t>K는 보통 수백–수천, GPU에서 한꺼번에 rollout한다</a:t>
             </a:r>
           </a:p>
         </p:txBody>
@@ -11907,7 +11907,7 @@
                 <a:ea typeface="Malgun Gothic"/>
                 <a:cs typeface="Malgun Gothic"/>
               </a:rPr>
-              <a:t>첫 명령을 실행하고 명령열을 한 칸 밀어 다음 주기의 시작값으로</a:t>
+              <a:t>첫 명령을 실행하고 명령열을 한 스텝 밀어 다음 주기의 시작값으로</a:t>
             </a:r>
           </a:p>
         </p:txBody>
@@ -12210,7 +12210,7 @@
                 <a:ea typeface="Malgun Gothic"/>
                 <a:cs typeface="Malgun Gothic"/>
               </a:rPr>
-              <a:t>온도는 몇 개의 표본을 믿을지 정한다</a:t>
+              <a:t>온도는 몇 개의 샘플을 믿을지 정한다</a:t>
             </a:r>
           </a:p>
         </p:txBody>
@@ -12308,7 +12308,7 @@
                 <a:ea typeface="Malgun Gothic"/>
                 <a:cs typeface="Malgun Gothic"/>
               </a:rPr>
-              <a:t>넓고 얕은 골짜기, 좁고 깊은 골짜기, 가운데 언덕이 있는 비용. 같은 표본 64개를 세 온도로 가중했다(빨간 선이 가중 평균)</a:t>
+              <a:t>넓고 얕은 골짜기, 좁고 깊은 골짜기, 가운데 언덕이 있는 비용. 같은 샘플 64개를 세 온도로 가중했다(빨간 선이 가중 평균)</a:t>
             </a:r>
           </a:p>
         </p:txBody>
@@ -12570,7 +12570,7 @@
                 <a:ea typeface="Malgun Gothic"/>
                 <a:cs typeface="Malgun Gothic"/>
               </a:rPr>
-              <a:t>가장 좋은 표본 하나에 몰린다. 빠르게 좋은 곳으로 가지만 잡음에 휘둘려 명령이 튄다.</a:t>
+              <a:t>가장 좋은 샘플 하나에 몰린다. 빠르게 좋은 곳으로 가지만 잡음에 휘둘려 명령이 튄다.</a:t>
             </a:r>
           </a:p>
         </p:txBody>
@@ -12832,7 +12832,7 @@
                 <a:ea typeface="Malgun Gothic"/>
                 <a:cs typeface="Malgun Gothic"/>
               </a:rPr>
-              <a:t>모든 표본의 평균에 가깝다. 매끄럽지만 두 골짜기 사이 언덕(장애물)으로 갈 수 있다.</a:t>
+              <a:t>모든 샘플의 평균에 가깝다. 매끄럽지만 두 골짜기 사이 언덕(장애물)으로 갈 수 있다.</a:t>
             </a:r>
           </a:p>
         </p:txBody>
@@ -13121,7 +13121,7 @@
                 <a:ea typeface="Malgun Gothic"/>
                 <a:cs typeface="Malgun Gothic"/>
               </a:rPr>
-              <a:t>지평 4초 동안의 제어 섭동 5개씩. 백색 잡음은 스텝마다 튀고, AR(1)은 이웃 스텝이 닮고, 변화율에 넣고 적분하면(SMPPI) 매끄럽다</a:t>
+              <a:t>horizon 4초 동안의 제어 섭동 5개씩. 백색 잡음은 스텝마다 튀고, AR(1)은 이웃 스텝이 닮고, 변화율에 넣고 적분하면(SMPPI) 매끄럽다</a:t>
             </a:r>
           </a:p>
         </p:txBody>
@@ -13145,9 +13145,9 @@
                 <a:tableStyleId>{5C22544A-7EE6-4342-B048-85BDC9FD1C3A}</a:tableStyleId>
               </a:tblPr>
               <a:tblGrid>
-                <a:gridCol w="3232745"/>
-                <a:gridCol w="3901877"/>
-                <a:gridCol w="3634978"/>
+                <a:gridCol w="3403203"/>
+                <a:gridCol w="3813572"/>
+                <a:gridCol w="3552825"/>
               </a:tblGrid>
               <a:tr h="292814">
                 <a:tc>
@@ -13312,7 +13312,7 @@
                           <a:ea typeface="Malgun Gothic"/>
                           <a:cs typeface="Malgun Gothic"/>
                         </a:rPr>
-                        <a:t>시간 상관(AR(1), 색 잡음)</a:t>
+                        <a:t>시간 상관(AR(1), 유색 잡음)</a:t>
                       </a:r>
                     </a:p>
                   </a:txBody>
@@ -13649,7 +13649,7 @@
                 <a:ea typeface="Malgun Gothic"/>
                 <a:cs typeface="Malgun Gothic"/>
               </a:rPr>
-              <a:t>십 년 동안 바뀐 것은 가중 평균이 아니라 표본 분포와 구현이다</a:t>
+              <a:t>십 년 동안 바뀐 것은 가중 평균이 아니라 샘플 분포와 구현이다</a:t>
             </a:r>
           </a:p>
         </p:txBody>
@@ -13664,7 +13664,7 @@
         </p:nvGraphicFramePr>
         <p:xfrm>
           <a:off x="711200" y="1361678"/>
-          <a:ext cx="10769601" cy="2501826"/>
+          <a:ext cx="10769600" cy="2501826"/>
         </p:xfrm>
         <a:graphic>
           <a:graphicData uri="http://schemas.openxmlformats.org/drawingml/2006/table">
@@ -13673,9 +13673,9 @@
                 <a:tableStyleId>{5C22544A-7EE6-4342-B048-85BDC9FD1C3A}</a:tableStyleId>
               </a:tblPr>
               <a:tblGrid>
-                <a:gridCol w="1554262"/>
-                <a:gridCol w="3259237"/>
-                <a:gridCol w="5956102"/>
+                <a:gridCol w="1511300"/>
+                <a:gridCol w="3169245"/>
+                <a:gridCol w="6089055"/>
               </a:tblGrid>
               <a:tr h="285477">
                 <a:tc>
@@ -13814,7 +13814,7 @@
                           <a:ea typeface="Malgun Gothic"/>
                           <a:cs typeface="Malgun Gothic"/>
                         </a:rPr>
-                        <a:t>경로 적분 제어를 GPU 표본 MPC로, KL 유도로 일반화</a:t>
+                        <a:t>경로 적분 제어를 GPU 샘플 기반 MPC로, KL 유도로 일반화</a:t>
                       </a:r>
                     </a:p>
                   </a:txBody>
@@ -13962,7 +13962,7 @@
                           <a:ea typeface="Malgun Gothic"/>
                           <a:cs typeface="Malgun Gothic"/>
                         </a:rPr>
-                        <a:t>정규 × 로그정규 분포에서 표본해 실행 가능한 궤적을 늘린다</a:t>
+                        <a:t>정규 × 로그정규 분포에서 샘플링해 실행 가능한 궤적을 늘린다</a:t>
                       </a:r>
                     </a:p>
                   </a:txBody>
@@ -14184,7 +14184,7 @@
                           <a:ea typeface="Malgun Gothic"/>
                           <a:cs typeface="Malgun Gothic"/>
                         </a:rPr>
-                        <a:t>C++/CUDA 템플릿, 표본 128개에 약 0.15 ms(RTX 3080)</a:t>
+                        <a:t>C++/CUDA 템플릿, 샘플 128개에 약 0.15 ms(RTX 3080)</a:t>
                       </a:r>
                     </a:p>
                   </a:txBody>
@@ -14258,7 +14258,7 @@
                           <a:ea typeface="Malgun Gothic"/>
                           <a:cs typeface="Malgun Gothic"/>
                         </a:rPr>
-                        <a:t>반복마다 잡음을 줄이는 확산식 담금질(4족 관절 토크)</a:t>
+                        <a:t>반복마다 잡음을 줄이는 diffusion식 annealing(4족 관절 토크)</a:t>
                       </a:r>
                     </a:p>
                   </a:txBody>
@@ -14332,7 +14332,7 @@
                           <a:ea typeface="Malgun Gothic"/>
                           <a:cs typeface="Malgun Gothic"/>
                         </a:rPr>
-                        <a:t>rollout에서 되먹임 이득을 얻어 풀이 사이와 지연을 메운다</a:t>
+                        <a:t>rollout에서 피드백 이득을 얻어 풀이 사이와 지연을 메운다</a:t>
                       </a:r>
                     </a:p>
                   </a:txBody>
@@ -14547,7 +14547,7 @@
                 <a:ea typeface="Malgun Gothic"/>
                 <a:cs typeface="Malgun Gothic"/>
               </a:rPr>
-              <a:t>되먹임에서 출발해 최적화와 안전으로 넓혀 간다</a:t>
+              <a:t>피드백에서 출발해 최적화와 안전으로 넓혀 간다</a:t>
             </a:r>
           </a:p>
         </p:txBody>
@@ -14712,7 +14712,7 @@
                           <a:ea typeface="Malgun Gothic"/>
                           <a:cs typeface="Malgun Gothic"/>
                         </a:rPr>
-                        <a:t>제어기는 무엇을 받아 무엇을 내나? 되먹임은 왜 필요한가?</a:t>
+                        <a:t>제어기는 무엇을 받아 무엇을 내나? 피드백은 왜 필요한가?</a:t>
                       </a:r>
                     </a:p>
                   </a:txBody>
@@ -14910,7 +14910,7 @@
                           <a:ea typeface="Malgun Gothic"/>
                           <a:cs typeface="Malgun Gothic"/>
                         </a:rPr>
-                        <a:t>표본 기반 MPC: MPPI</a:t>
+                        <a:t>샘플 기반 MPC: MPPI</a:t>
                       </a:r>
                     </a:p>
                   </a:txBody>
@@ -14934,7 +14934,7 @@
                           <a:ea typeface="Malgun Gothic"/>
                           <a:cs typeface="Malgun Gothic"/>
                         </a:rPr>
-                        <a:t>미분 없이, 비매끄러운 비용으로 최적화하려면?</a:t>
+                        <a:t>미분 없이, non-smooth 비용으로 최적화하려면?</a:t>
                       </a:r>
                     </a:p>
                   </a:txBody>
@@ -15274,7 +15274,7 @@
                 <a:ea typeface="Malgun Gothic"/>
                 <a:cs typeface="Malgun Gothic"/>
               </a:rPr>
-              <a:t>학습한 prior는 표본의 중심이 아니라 비용으로 넣는다</a:t>
+              <a:t>학습한 prior는 샘플의 중심이 아니라 비용으로 넣는다</a:t>
             </a:r>
           </a:p>
         </p:txBody>
@@ -15414,7 +15414,7 @@
                 <a:ea typeface="Malgun Gothic"/>
                 <a:cs typeface="Malgun Gothic"/>
               </a:rPr>
-              <a:t>(왼쪽)는 매번 표본 중심을 prior로 되돌린다. 최적화기가 쌓은 보정을 버린다.</a:t>
+              <a:t>(왼쪽)는 매번 샘플 중심을 prior로 되돌린다. 최적화기가 쌓은 보정을 버린다.</a:t>
             </a:r>
           </a:p>
         </p:txBody>
@@ -15468,7 +15468,7 @@
                 <a:ea typeface="Malgun Gothic"/>
                 <a:cs typeface="Malgun Gothic"/>
               </a:rPr>
-              <a:t>(오른쪽)는 이전 해를 중심으로 표본하고 prior는 근접 비용으로만 둔다.</a:t>
+              <a:t>(오른쪽)는 이전 해를 중심으로 샘플링하고 prior는 proximal 비용으로만 둔다.</a:t>
             </a:r>
           </a:p>
         </p:txBody>
@@ -15692,7 +15692,7 @@
                 <a:ea typeface="Malgun Gothic"/>
                 <a:cs typeface="Malgun Gothic"/>
               </a:rPr>
-              <a:t> 학습 Planner나 정책의 출력을 표본 기반 제어기에 넣을 때, "믿는 정도"를 비용 가중치 α로 조절할 수 있다.</a:t>
+              <a:t> 학습 Planner나 정책의 출력을 샘플 기반 제어기에 넣을 때, "믿는 정도"를 비용 가중치 α로 조절할 수 있다.</a:t>
             </a:r>
           </a:p>
         </p:txBody>
@@ -15897,7 +15897,7 @@
                 <a:ea typeface="Malgun Gothic"/>
                 <a:cs typeface="Malgun Gothic"/>
               </a:rPr>
-              <a:t>MPPI는 미분을 버린 대신 표본 수와 온도에 기댄다</a:t>
+              <a:t>MPPI는 미분을 버린 대신 샘플 수와 온도에 기댄다</a:t>
             </a:r>
           </a:p>
         </p:txBody>
@@ -15921,9 +15921,9 @@
                 <a:tableStyleId>{5C22544A-7EE6-4342-B048-85BDC9FD1C3A}</a:tableStyleId>
               </a:tblPr>
               <a:tblGrid>
-                <a:gridCol w="1621830"/>
-                <a:gridCol w="3784699"/>
-                <a:gridCol w="5363071"/>
+                <a:gridCol w="1564680"/>
+                <a:gridCol w="4030960"/>
+                <a:gridCol w="5173960"/>
               </a:tblGrid>
               <a:tr h="300067">
                 <a:tc>
@@ -15952,7 +15952,7 @@
                           <a:ea typeface="Malgun Gothic"/>
                           <a:cs typeface="Malgun Gothic"/>
                         </a:rPr>
-                        <a:t>기울기 기반 MPC(NMPC)</a:t>
+                        <a:t>gradient 기반 MPC(NMPC)</a:t>
                       </a:r>
                     </a:p>
                   </a:txBody>
@@ -15976,7 +15976,7 @@
                           <a:ea typeface="Malgun Gothic"/>
                           <a:cs typeface="Malgun Gothic"/>
                         </a:rPr>
-                        <a:t>표본 기반 MPC(MPPI)</a:t>
+                        <a:t>샘플 기반 MPC(MPPI)</a:t>
                       </a:r>
                     </a:p>
                   </a:txBody>
@@ -16124,7 +16124,7 @@
                           <a:ea typeface="Malgun Gothic"/>
                           <a:cs typeface="Malgun Gothic"/>
                         </a:rPr>
-                        <a:t>벌점·확률 제약으로 근사</a:t>
+                        <a:t>페널티·확률 제약으로 근사</a:t>
                       </a:r>
                     </a:p>
                   </a:txBody>
@@ -16198,7 +16198,7 @@
                           <a:ea typeface="Malgun Gothic"/>
                           <a:cs typeface="Malgun Gothic"/>
                         </a:rPr>
-                        <a:t>표본 범위 안의 근사 최적</a:t>
+                        <a:t>샘플 범위 안의 근사 최적</a:t>
                       </a:r>
                     </a:p>
                   </a:txBody>
@@ -16322,7 +16322,7 @@
                           <a:ea typeface="Malgun Gothic"/>
                           <a:cs typeface="Malgun Gothic"/>
                         </a:rPr>
-                        <a:t>긴 지평·많은 입력도</a:t>
+                        <a:t>긴 horizon·많은 입력도</a:t>
                       </a:r>
                     </a:p>
                   </a:txBody>
@@ -16346,7 +16346,7 @@
                           <a:ea typeface="Malgun Gothic"/>
                           <a:cs typeface="Malgun Gothic"/>
                         </a:rPr>
-                        <a:t>입력 차원이 크면 표본이 많이 든다</a:t>
+                        <a:t>입력 차원이 크면 샘플이 많이 든다</a:t>
                       </a:r>
                     </a:p>
                   </a:txBody>
@@ -16420,7 +16420,7 @@
                           <a:ea typeface="Malgun Gothic"/>
                           <a:cs typeface="Malgun Gothic"/>
                         </a:rPr>
-                        <a:t>표본 수, 온도, 잡음 공분산</a:t>
+                        <a:t>샘플 수, 온도, 잡음 공분산</a:t>
                       </a:r>
                     </a:p>
                   </a:txBody>
@@ -16513,7 +16513,7 @@
                 <a:ea typeface="Malgun Gothic"/>
                 <a:cs typeface="Malgun Gothic"/>
               </a:rPr>
-              <a:t> 비용이 비매끄러우면 MPPI, hard 제약과 정밀함이 중요하면 NMPC. 둘을 같은 벤치마크에서 견주는 것이 가장 확실하다.</a:t>
+              <a:t> 비용이 매끄럽지 않으면 MPPI, hard 제약과 정밀함이 중요하면 NMPC. 둘을 같은 벤치마크에서 견주는 것이 가장 확실하다.</a:t>
             </a:r>
           </a:p>
         </p:txBody>
@@ -17148,7 +17148,7 @@
                 <a:ea typeface="Malgun Gothic"/>
                 <a:cs typeface="Malgun Gothic"/>
               </a:rPr>
-              <a:t>계산 시간, 통신, 모터 드라이버, 바퀴 조향처럼 1차 지연을 가진 구동기.</a:t>
+              <a:t>계산 시간, 통신, 모터 드라이버, 바퀴 조향처럼 1차 지연을 가진 액추에이터.</a:t>
             </a:r>
           </a:p>
         </p:txBody>
@@ -17739,7 +17739,7 @@
                 <a:ea typeface="Malgun Gothic"/>
                 <a:cs typeface="Malgun Gothic"/>
               </a:rPr>
-              <a:t>4 · 표본 기반 제어의 지연</a:t>
+              <a:t>4 · 샘플 기반 제어의 지연</a:t>
             </a:r>
           </a:p>
         </p:txBody>
@@ -18042,7 +18042,7 @@
                 <a:ea typeface="Malgun Gothic"/>
                 <a:cs typeface="Malgun Gothic"/>
               </a:rPr>
-              <a:t>지연을 초기 상태 분포로 두고 rollout마다 시작점을 섭동한다. 가중 rollout의 회귀로 되먹임 이득을 얻는다. UR5e 실물 5회에서 MPPI는 2번 충돌, CLIS-MPPI는 0번.</a:t>
+              <a:t>지연을 초기 상태 분포로 두고 rollout마다 시작점을 섭동한다. 가중 rollout의 회귀로 피드백 이득을 얻는다. UR5e 실물 5회에서 MPPI는 2번 충돌, CLIS-MPPI는 0번.</a:t>
             </a:r>
           </a:p>
         </p:txBody>
@@ -18318,11 +18318,11 @@
         <p:spPr>
           <a:xfrm>
             <a:off x="711200" y="3914279"/>
-            <a:ext cx="5257800" cy="830560"/>
+            <a:ext cx="5257800" cy="1051520"/>
           </a:xfrm>
           <a:prstGeom prst="roundRect">
             <a:avLst>
-              <a:gd name="adj" fmla="val 9174"/>
+              <a:gd name="adj" fmla="val 7246"/>
             </a:avLst>
           </a:prstGeom>
           <a:solidFill>
@@ -18378,7 +18378,7 @@
         <p:spPr>
           <a:xfrm>
             <a:off x="5962650" y="3914279"/>
-            <a:ext cx="6350" cy="830560"/>
+            <a:ext cx="6350" cy="1051520"/>
           </a:xfrm>
           <a:prstGeom prst="rect">
             <a:avLst/>
@@ -18406,7 +18406,7 @@
         </p:nvSpPr>
         <p:spPr>
           <a:xfrm>
-            <a:off x="711200" y="4738489"/>
+            <a:off x="711200" y="4959449"/>
             <a:ext cx="5257800" cy="6350"/>
           </a:xfrm>
           <a:prstGeom prst="rect">
@@ -18436,7 +18436,7 @@
         <p:spPr>
           <a:xfrm>
             <a:off x="711200" y="3914279"/>
-            <a:ext cx="50800" cy="830560"/>
+            <a:ext cx="50800" cy="1051520"/>
           </a:xfrm>
           <a:prstGeom prst="roundRect">
             <a:avLst>
@@ -18539,7 +18539,7 @@
         <p:spPr>
           <a:xfrm>
             <a:off x="927100" y="4377829"/>
-            <a:ext cx="5041964" cy="327000"/>
+            <a:ext cx="5041964" cy="603200"/>
           </a:xfrm>
           <a:prstGeom prst="rect">
             <a:avLst/>
@@ -18566,7 +18566,7 @@
                 <a:ea typeface="Malgun Gothic"/>
                 <a:cs typeface="Malgun Gothic"/>
               </a:rPr>
-              <a:t>비용이 계단 같아 기울기가 거의 없으면 회귀 이득(CLIS), 매끄러우면 미분 이득.</a:t>
+              <a:t>비용이 계단 같아 gradient가 거의 없으면 회귀 이득(CLIS), 매끄러우면 미분 이득.</a:t>
             </a:r>
           </a:p>
         </p:txBody>
@@ -18762,7 +18762,7 @@
                 <a:ea typeface="Malgun Gothic"/>
                 <a:cs typeface="Malgun Gothic"/>
               </a:rPr>
-              <a:t>CLIS-MPPI (Fig. 2): 초기 상태 표본, 가중 rollout, 회귀 이득</a:t>
+              <a:t>CLIS-MPPI (Fig. 2): 초기 상태 샘플, 가중 rollout, 회귀 이득</a:t>
             </a:r>
           </a:p>
         </p:txBody>
@@ -18992,8 +18992,8 @@
               </a:tblPr>
               <a:tblGrid>
                 <a:gridCol w="528340"/>
-                <a:gridCol w="1054695"/>
-                <a:gridCol w="3674765"/>
+                <a:gridCol w="1463774"/>
+                <a:gridCol w="3265686"/>
               </a:tblGrid>
               <a:tr h="278224">
                 <a:tc>
@@ -19132,7 +19132,7 @@
                           <a:ea typeface="Malgun Gothic"/>
                           <a:cs typeface="Malgun Gothic"/>
                         </a:rPr>
-                        <a:t>확률 신경망 앙상블 동역학 + 궤적 표본 계획. half-cheetah에서 SAC보다 8배 적은 표본</a:t>
+                        <a:t>확률 신경망 앙상블 동역학 + 궤적 샘플링 계획. half-cheetah에서 SAC보다 8배 적은 샘플</a:t>
                       </a:r>
                     </a:p>
                   </a:txBody>
@@ -19206,7 +19206,7 @@
                           <a:ea typeface="Malgun Gothic"/>
                           <a:cs typeface="Malgun Gothic"/>
                         </a:rPr>
-                        <a:t>IMU를 넣은 역운동 모델로 고속 오프로드 추종. 성공률 52.4% → 86.9%</a:t>
+                        <a:t>IMU를 넣은 inverse kinodynamic 모델로 고속 오프로드 추종. 성공률 52.4% → 86.9%</a:t>
                       </a:r>
                     </a:p>
                   </a:txBody>
@@ -19280,7 +19280,7 @@
                           <a:ea typeface="Malgun Gothic"/>
                           <a:cs typeface="Malgun Gothic"/>
                         </a:rPr>
-                        <a:t>환경 요인을 잠재 벡터로, 배포 때는 이력에서 추정</a:t>
+                        <a:t>환경 요인을 latent 벡터로, 배포 때는 이력에서 추정</a:t>
                       </a:r>
                     </a:p>
                   </a:txBody>
@@ -19330,7 +19330,7 @@
                           <a:ea typeface="Malgun Gothic"/>
                           <a:cs typeface="Malgun Gothic"/>
                         </a:rPr>
-                        <a:t>지형 인지 운동 모델</a:t>
+                        <a:t>지형 인지 kinodynamic 모델</a:t>
                       </a:r>
                     </a:p>
                   </a:txBody>
@@ -19354,7 +19354,7 @@
                           <a:ea typeface="Malgun Gothic"/>
                           <a:cs typeface="Malgun Gothic"/>
                         </a:rPr>
-                        <a:t>6자유도 운동 예측 + MPPI로 위험한 궤적에 벌점</a:t>
+                        <a:t>6자유도 운동 예측 + MPPI로 위험한 궤적에 페널티</a:t>
                       </a:r>
                     </a:p>
                   </a:txBody>
@@ -19428,7 +19428,7 @@
                           <a:ea typeface="Malgun Gothic"/>
                           <a:cs typeface="Malgun Gothic"/>
                         </a:rPr>
-                        <a:t>디코더 없는 잠재 world model 안에서 MPPI</a:t>
+                        <a:t>디코더 없는 latent world model 안에서 MPPI</a:t>
                       </a:r>
                     </a:p>
                   </a:txBody>
@@ -19536,7 +19536,7 @@
                 <a:ea typeface="Malgun Gothic"/>
                 <a:cs typeface="Malgun Gothic"/>
               </a:rPr>
-              <a:t>지형 인지 운동 모델 + MPPI (Fig. 1): 지형이 차량 운동에 주는 영향을 예측해 위험한 궤적에 벌점 — arXiv:2305.00676</a:t>
+              <a:t>지형 인지 kinodynamic 모델 + MPPI (Fig. 1): 지형이 차량 운동에 주는 영향을 예측해 위험한 궤적에 페널티 — arXiv:2305.00676</a:t>
             </a:r>
           </a:p>
         </p:txBody>
@@ -19700,7 +19700,7 @@
                 <a:ea typeface="Malgun Gothic"/>
                 <a:cs typeface="Malgun Gothic"/>
               </a:rPr>
-              <a:t>4 · 잔차와 문맥</a:t>
+              <a:t>4 · 잔차와 context</a:t>
             </a:r>
           </a:p>
         </p:txBody>
@@ -19741,7 +19741,7 @@
                 <a:ea typeface="Malgun Gothic"/>
                 <a:cs typeface="Malgun Gothic"/>
               </a:rPr>
-              <a:t>물리 모델 위에 작은 학습 잔차를 얹고, 짧은 이력으로 조건을 나른다</a:t>
+              <a:t>물리 모델 위에 작은 학습 잔차를 얹고, 짧은 이력으로 조건을 전달한다</a:t>
             </a:r>
           </a:p>
         </p:txBody>
@@ -20351,7 +20351,7 @@
                 <a:ea typeface="Malgun Gothic"/>
                 <a:cs typeface="Malgun Gothic"/>
               </a:rPr>
-              <a:t>0.4초 이력의 12차원 잠재로 잔차를 조건화, 재생 버퍼로 기억.</a:t>
+              <a:t>0.4초 이력의 12차원 latent로 잔차를 조건화, replay 버퍼로 기억.</a:t>
             </a:r>
           </a:p>
         </p:txBody>
@@ -20365,11 +20365,11 @@
         <p:spPr>
           <a:xfrm>
             <a:off x="711200" y="4320977"/>
-            <a:ext cx="5257800" cy="830560"/>
+            <a:ext cx="5257800" cy="1051520"/>
           </a:xfrm>
           <a:prstGeom prst="roundRect">
             <a:avLst>
-              <a:gd name="adj" fmla="val 9174"/>
+              <a:gd name="adj" fmla="val 7246"/>
             </a:avLst>
           </a:prstGeom>
           <a:solidFill>
@@ -20425,7 +20425,7 @@
         <p:spPr>
           <a:xfrm>
             <a:off x="5962650" y="4320977"/>
-            <a:ext cx="6350" cy="830560"/>
+            <a:ext cx="6350" cy="1051520"/>
           </a:xfrm>
           <a:prstGeom prst="rect">
             <a:avLst/>
@@ -20453,7 +20453,7 @@
         </p:nvSpPr>
         <p:spPr>
           <a:xfrm>
-            <a:off x="711200" y="5145187"/>
+            <a:off x="711200" y="5366147"/>
             <a:ext cx="5257800" cy="6350"/>
           </a:xfrm>
           <a:prstGeom prst="rect">
@@ -20483,7 +20483,7 @@
         <p:spPr>
           <a:xfrm>
             <a:off x="711200" y="4320977"/>
-            <a:ext cx="50800" cy="830560"/>
+            <a:ext cx="50800" cy="1051520"/>
           </a:xfrm>
           <a:prstGeom prst="roundRect">
             <a:avLst>
@@ -20586,7 +20586,7 @@
         <p:spPr>
           <a:xfrm>
             <a:off x="927100" y="4784527"/>
-            <a:ext cx="5041964" cy="327000"/>
+            <a:ext cx="5041964" cy="603200"/>
           </a:xfrm>
           <a:prstGeom prst="rect">
             <a:avLst/>
@@ -20613,7 +20613,7 @@
                 <a:ea typeface="Malgun Gothic"/>
                 <a:cs typeface="Malgun Gothic"/>
               </a:rPr>
-              <a:t>약 5초 이력을 문맥 토큰 하나로. 6 m/s 추종 오차가 기준 대비 42–57% 작다.</a:t>
+              <a:t>약 5초 이력을 context 토큰 하나로. 6 m/s 추종 오차가 기준 대비 42–57% 작다.</a:t>
             </a:r>
           </a:p>
         </p:txBody>
@@ -20711,7 +20711,7 @@
                 <a:ea typeface="Malgun Gothic"/>
                 <a:cs typeface="Malgun Gothic"/>
               </a:rPr>
-              <a:t>OptCar (Fig. 2): 이력을 문맥 벡터 하나로 압축해 rollout을 조건화한다 — arXiv:2607.13319</a:t>
+              <a:t>OptCar (Fig. 2): 이력을 context 벡터 하나로 압축해 rollout을 조건화한다 — arXiv:2607.13319</a:t>
             </a:r>
           </a:p>
         </p:txBody>
@@ -20875,7 +20875,7 @@
                 <a:ea typeface="Malgun Gothic"/>
                 <a:cs typeface="Malgun Gothic"/>
               </a:rPr>
-              <a:t>4 · 배경지식 · 가우시안 과정</a:t>
+              <a:t>4 · 배경지식 · 가우시안 프로세스</a:t>
             </a:r>
           </a:p>
         </p:txBody>
@@ -21100,7 +21100,7 @@
                 <a:ea typeface="Malgun Gothic"/>
                 <a:cs typeface="Malgun Gothic"/>
               </a:rPr>
-              <a:t>잔차 표본 14개로 맞춘 GP와 선형 회귀. GP는 자료 근처에서 비선형을 맞추고 자료 밖에서 σ가 커진다</a:t>
+              <a:t>잔차 샘플 14개로 피팅한 GP와 선형 회귀. GP는 데이터 근처에서 비선형을 맞추고 데이터 분포 밖에서 σ가 커진다</a:t>
             </a:r>
           </a:p>
         </p:txBody>
@@ -21362,7 +21362,7 @@
                 <a:ea typeface="Malgun Gothic"/>
                 <a:cs typeface="Malgun Gothic"/>
               </a:rPr>
-              <a:t>적은 자료로 비선형을 맞춘다. σ를 확률 제약·튜브의 폭으로 쓸 수 있다.</a:t>
+              <a:t>적은 데이터로 비선형을 맞춘다. σ를 확률 제약·튜브의 폭으로 쓸 수 있다.</a:t>
             </a:r>
           </a:p>
         </p:txBody>
@@ -21624,7 +21624,7 @@
                 <a:ea typeface="Malgun Gothic"/>
                 <a:cs typeface="Malgun Gothic"/>
               </a:rPr>
-              <a:t>계산이 자료 수의 세제곱. 커널 선택에 결과가 달렸다. 큰 몫이 선형이면 선형 회귀로 충분하다.</a:t>
+              <a:t>계산이 데이터 수의 세제곱. 커널 선택에 결과가 달렸다. 대부분이 선형이면 선형 회귀로 충분하다.</a:t>
             </a:r>
           </a:p>
         </p:txBody>
@@ -21802,7 +21802,7 @@
         <p:spPr>
           <a:xfrm>
             <a:off x="711200" y="781050"/>
-            <a:ext cx="11118088" cy="554335"/>
+            <a:ext cx="11118088" cy="1057870"/>
           </a:xfrm>
           <a:prstGeom prst="rect">
             <a:avLst/>
@@ -21829,7 +21829,7 @@
                 <a:ea typeface="Malgun Gothic"/>
                 <a:cs typeface="Malgun Gothic"/>
               </a:rPr>
-              <a:t>숨은 조건은 학습 때 특권 정보로 배우고, 배포 때 이력에서 추정한다</a:t>
+              <a:t>숨은 조건은 학습 때 privileged 정보로 배우고, 배포 때 이력에서 추정한다</a:t>
             </a:r>
           </a:p>
         </p:txBody>
@@ -21842,7 +21842,7 @@
         </p:nvSpPr>
         <p:spPr>
           <a:xfrm>
-            <a:off x="711200" y="1361678"/>
+            <a:off x="711200" y="1764506"/>
             <a:ext cx="5257800" cy="2286000"/>
           </a:xfrm>
           <a:prstGeom prst="roundRect">
@@ -21883,7 +21883,7 @@
         </p:blipFill>
         <p:spPr>
           <a:xfrm>
-            <a:off x="1616118" y="1361678"/>
+            <a:off x="1616118" y="1764506"/>
             <a:ext cx="3447964" cy="2286000"/>
           </a:xfrm>
           <a:prstGeom prst="rect">
@@ -21899,7 +21899,7 @@
         </p:nvSpPr>
         <p:spPr>
           <a:xfrm>
-            <a:off x="711200" y="3711178"/>
+            <a:off x="711200" y="4114006"/>
             <a:ext cx="5440934" cy="495300"/>
           </a:xfrm>
           <a:prstGeom prst="rect">
@@ -21927,7 +21927,7 @@
                 <a:ea typeface="Malgun Gothic"/>
                 <a:cs typeface="Malgun Gothic"/>
               </a:rPr>
-              <a:t>RMA (Fig. 2): 특권 환경 요인을 잠재로 압축하고, 적응 모듈이 이력으로 추정한다 — arXiv:2107.04034</a:t>
+              <a:t>RMA (Fig. 2): privileged 환경 요인을 latent로 압축하고, 적응 모듈이 이력으로 추정한다 — arXiv:2107.04034</a:t>
             </a:r>
           </a:p>
         </p:txBody>
@@ -21940,7 +21940,7 @@
         </p:nvSpPr>
         <p:spPr>
           <a:xfrm>
-            <a:off x="6223000" y="1361678"/>
+            <a:off x="6223000" y="1764506"/>
             <a:ext cx="5257800" cy="1905000"/>
           </a:xfrm>
           <a:prstGeom prst="roundRect">
@@ -21981,7 +21981,7 @@
         </p:blipFill>
         <p:spPr>
           <a:xfrm>
-            <a:off x="6483522" y="1361678"/>
+            <a:off x="6483522" y="1764506"/>
             <a:ext cx="4736757" cy="1905000"/>
           </a:xfrm>
           <a:prstGeom prst="rect">
@@ -21997,7 +21997,7 @@
         </p:nvSpPr>
         <p:spPr>
           <a:xfrm>
-            <a:off x="6223000" y="3330178"/>
+            <a:off x="6223000" y="3733006"/>
             <a:ext cx="5440934" cy="273050"/>
           </a:xfrm>
           <a:prstGeom prst="rect">
@@ -22025,7 +22025,7 @@
                 <a:ea typeface="Malgun Gothic"/>
                 <a:cs typeface="Malgun Gothic"/>
               </a:rPr>
-              <a:t>메타학습 적응의 장난감: 메타 시작점은 처음부터 새 노면의 오차가 작고, 한두 스텝 적응으로 더 준다</a:t>
+              <a:t>메타학습 적응의 toy 예제: 메타 시작점은 처음부터 새 노면의 오차가 작고, 한두 스텝 적응으로 더 준다</a:t>
             </a:r>
           </a:p>
         </p:txBody>
@@ -22039,8 +22039,8 @@
           <p:nvPr/>
         </p:nvGraphicFramePr>
         <p:xfrm>
-          <a:off x="711200" y="4244578"/>
-          <a:ext cx="10769600" cy="1114921"/>
+          <a:off x="711200" y="4647406"/>
+          <a:ext cx="10769601" cy="1114921"/>
         </p:xfrm>
         <a:graphic>
           <a:graphicData uri="http://schemas.openxmlformats.org/drawingml/2006/table">
@@ -22049,10 +22049,10 @@
                 <a:tableStyleId>{5C22544A-7EE6-4342-B048-85BDC9FD1C3A}</a:tableStyleId>
               </a:tblPr>
               <a:tblGrid>
-                <a:gridCol w="3233936"/>
-                <a:gridCol w="2105918"/>
-                <a:gridCol w="2044601"/>
-                <a:gridCol w="3385145"/>
+                <a:gridCol w="3280073"/>
+                <a:gridCol w="2328466"/>
+                <a:gridCol w="1943398"/>
+                <a:gridCol w="3217664"/>
               </a:tblGrid>
               <a:tr h="285477">
                 <a:tc>
@@ -22167,7 +22167,7 @@
                           <a:ea typeface="Malgun Gothic"/>
                           <a:cs typeface="Malgun Gothic"/>
                         </a:rPr>
-                        <a:t>이력 → 잠재(RMA, OptCar)</a:t>
+                        <a:t>이력 → latent(RMA, OptCar)</a:t>
                       </a:r>
                     </a:p>
                   </a:txBody>
@@ -22191,7 +22191,7 @@
                           <a:ea typeface="Malgun Gothic"/>
                           <a:cs typeface="Malgun Gothic"/>
                         </a:rPr>
-                        <a:t>잠재 벡터</a:t>
+                        <a:t>latent 벡터</a:t>
                       </a:r>
                     </a:p>
                   </a:txBody>
@@ -22387,7 +22387,7 @@
                           <a:ea typeface="Malgun Gothic"/>
                           <a:cs typeface="Malgun Gothic"/>
                         </a:rPr>
-                        <a:t>가중치 몇 스텝</a:t>
+                        <a:t>가중치(몇 스텝 갱신)</a:t>
                       </a:r>
                     </a:p>
                   </a:txBody>
@@ -22553,7 +22553,7 @@
                 <a:ea typeface="Malgun Gothic"/>
                 <a:cs typeface="Malgun Gothic"/>
               </a:rPr>
-              <a:t>모델 오차를 다루는 법은 "얼마나 배우느냐"의 사다리다</a:t>
+              <a:t>모델 오차를 다루는 법은 "얼마나 배우느냐"에 따라 단계가 나뉜다</a:t>
             </a:r>
           </a:p>
         </p:txBody>
@@ -22568,7 +22568,7 @@
         </p:nvGraphicFramePr>
         <p:xfrm>
           <a:off x="711200" y="1361678"/>
-          <a:ext cx="10769600" cy="1757223"/>
+          <a:ext cx="10769601" cy="1757223"/>
         </p:xfrm>
         <a:graphic>
           <a:graphicData uri="http://schemas.openxmlformats.org/drawingml/2006/table">
@@ -22577,9 +22577,9 @@
                 <a:tableStyleId>{5C22544A-7EE6-4342-B048-85BDC9FD1C3A}</a:tableStyleId>
               </a:tblPr>
               <a:tblGrid>
-                <a:gridCol w="3024882"/>
-                <a:gridCol w="3531195"/>
-                <a:gridCol w="4213523"/>
+                <a:gridCol w="2841427"/>
+                <a:gridCol w="3530501"/>
+                <a:gridCol w="4397673"/>
               </a:tblGrid>
               <a:tr h="300067">
                 <a:tc>
@@ -22694,7 +22694,7 @@
                           <a:ea typeface="Malgun Gothic"/>
                           <a:cs typeface="Malgun Gothic"/>
                         </a:rPr>
-                        <a:t>해석 쉽고 자료가 거의 필요 없다</a:t>
+                        <a:t>해석 쉽고 데이터가 거의 필요 없다</a:t>
                       </a:r>
                     </a:p>
                   </a:txBody>
@@ -22792,7 +22792,7 @@
                           <a:ea typeface="Malgun Gothic"/>
                           <a:cs typeface="Malgun Gothic"/>
                         </a:rPr>
-                        <a:t>기저 선택에 묶인다</a:t>
+                        <a:t>기저 선택에 제한된다</a:t>
                       </a:r>
                     </a:p>
                   </a:txBody>
@@ -22866,7 +22866,7 @@
                           <a:ea typeface="Malgun Gothic"/>
                           <a:cs typeface="Malgun Gothic"/>
                         </a:rPr>
-                        <a:t>자료 밖에서 틀린다</a:t>
+                        <a:t>데이터 분포 밖에서 틀린다</a:t>
                       </a:r>
                     </a:p>
                   </a:txBody>
@@ -23014,7 +23014,7 @@
                           <a:ea typeface="Malgun Gothic"/>
                           <a:cs typeface="Malgun Gothic"/>
                         </a:rPr>
-                        <a:t>자료가 많이 들고 계획기가 오차를 이용</a:t>
+                        <a:t>데이터가 많이 들고 Planner가 오차를 이용</a:t>
                       </a:r>
                     </a:p>
                   </a:txBody>
@@ -23107,7 +23107,7 @@
                 <a:ea typeface="Malgun Gothic"/>
                 <a:cs typeface="Malgun Gothic"/>
               </a:rPr>
-              <a:t> 물리로 설명되는 것은 물리로, 남는 작은 몫만 배우고, 불확실성을 함께 낸다.</a:t>
+              <a:t> 물리로 설명되는 것은 물리로, 남는 작은 부분만 배우고, 불확실성을 함께 낸다.</a:t>
             </a:r>
           </a:p>
         </p:txBody>
@@ -23796,7 +23796,7 @@
                 <a:ea typeface="Malgun Gothic"/>
                 <a:cs typeface="Malgun Gothic"/>
               </a:rPr>
-              <a:t>2장의 LQR·이동 지평 → 4 비선형 MPC에서 깊게. 4장의 잔차·GP → 4 MPC 3장.</a:t>
+              <a:t>2장의 LQR·receding horizon → 4 비선형 MPC에서 깊게. 4장의 잔차·GP → 4 MPC 3장.</a:t>
             </a:r>
           </a:p>
         </p:txBody>
@@ -24058,7 +24058,7 @@
                 <a:ea typeface="Malgun Gothic"/>
                 <a:cs typeface="Malgun Gothic"/>
               </a:rPr>
-              <a:t>MPPI의 가중 평균은 5 강화학습 4장의 추론으로서의 제어와 같은 식이다. 지연 → 6 시뮬레이션의 지연 모델.</a:t>
+              <a:t>MPPI의 가중 평균은 5 강화학습 4장의 control as inference와 같은 식이다. 지연 → 6 시뮬레이션의 지연 모델.</a:t>
             </a:r>
           </a:p>
         </p:txBody>
@@ -25201,7 +25201,7 @@
                 <a:ea typeface="Malgun Gothic"/>
                 <a:cs typeface="Malgun Gothic"/>
               </a:rPr>
-              <a:t>감지 전 개입(OcclusionCBF): 가려진 곳의 도달 가능 점유를 추정한다</a:t>
+              <a:t>감지 전 개입(OcclusionCBF): 가려진 곳의 도달 가능 occupancy를 추정한다</a:t>
             </a:r>
           </a:p>
         </p:txBody>
@@ -26305,7 +26305,7 @@
                 <a:ea typeface="Malgun Gothic"/>
                 <a:cs typeface="Malgun Gothic"/>
               </a:rPr>
-              <a:t>평균 비용은 드문 큰 사고를 묻고, CVaR는 나쁜 꼬리를 본다</a:t>
+              <a:t>평균 비용은 드문 큰 사고를 가리고, CVaR는 나쁜 꼬리를 본다</a:t>
             </a:r>
           </a:p>
         </p:txBody>
@@ -26751,7 +26751,7 @@
                 <a:ea typeface="Malgun Gothic"/>
                 <a:cs typeface="Malgun Gothic"/>
               </a:rPr>
-              <a:t>평균만 본다. 드문 충돌을 묻는다.</a:t>
+              <a:t>평균만 본다. 드문 충돌을 가린다.</a:t>
             </a:r>
           </a:p>
         </p:txBody>
@@ -27481,7 +27481,7 @@
                 <a:ea typeface="Malgun Gothic"/>
                 <a:cs typeface="Malgun Gothic"/>
               </a:rPr>
-              <a:t>Conformal prediction: 보정 자료 n개의 오차 순위로 반경을 정하면, 분포 가정 없이 포함률 1−α가 보장된다. n이 작으면 실제 포함률이 흔들린다</a:t>
+              <a:t>Conformal prediction: 보정 데이터 n개의 오차 순위로 반경을 정하면, 분포 가정 없이 포함률 1−α가 보장된다. n이 작으면 실제 포함률이 흔들린다</a:t>
             </a:r>
           </a:p>
         </p:txBody>
@@ -27495,11 +27495,11 @@
         <p:spPr>
           <a:xfrm>
             <a:off x="6223000" y="1361678"/>
-            <a:ext cx="5257800" cy="1051520"/>
+            <a:ext cx="5257800" cy="1272480"/>
           </a:xfrm>
           <a:prstGeom prst="roundRect">
             <a:avLst>
-              <a:gd name="adj" fmla="val 7246"/>
+              <a:gd name="adj" fmla="val 5988"/>
             </a:avLst>
           </a:prstGeom>
           <a:solidFill>
@@ -27555,7 +27555,7 @@
         <p:spPr>
           <a:xfrm>
             <a:off x="11474450" y="1361678"/>
-            <a:ext cx="6350" cy="1051520"/>
+            <a:ext cx="6350" cy="1272480"/>
           </a:xfrm>
           <a:prstGeom prst="rect">
             <a:avLst/>
@@ -27583,7 +27583,7 @@
         </p:nvSpPr>
         <p:spPr>
           <a:xfrm>
-            <a:off x="6223000" y="2406848"/>
+            <a:off x="6223000" y="2627809"/>
             <a:ext cx="5257800" cy="6350"/>
           </a:xfrm>
           <a:prstGeom prst="rect">
@@ -27613,7 +27613,7 @@
         <p:spPr>
           <a:xfrm>
             <a:off x="6223000" y="1361678"/>
-            <a:ext cx="50800" cy="1051520"/>
+            <a:ext cx="50800" cy="1272480"/>
           </a:xfrm>
           <a:prstGeom prst="roundRect">
             <a:avLst>
@@ -27716,7 +27716,7 @@
         <p:spPr>
           <a:xfrm>
             <a:off x="6438900" y="1825228"/>
-            <a:ext cx="5041964" cy="603200"/>
+            <a:ext cx="5041964" cy="879401"/>
           </a:xfrm>
           <a:prstGeom prst="rect">
             <a:avLst/>
@@ -27743,7 +27743,7 @@
                 <a:ea typeface="Malgun Gothic"/>
                 <a:cs typeface="Malgun Gothic"/>
               </a:rPr>
-              <a:t>보행자 9명 성공률: Nav2 MPPI 47.83%, DRA-MPPI 50.38%, DUCCT-MPPI 77.97%. 불확실성을 과소신으로 두면 67.33%로 떨어진다(확률 희석).</a:t>
+              <a:t>보행자 9명 성공률: Nav2 MPPI 47.83%, DRA-MPPI 50.38%, DUCCT-MPPI 77.97%. 불확실성을 실제보다 크게 잡으면 67.33%로 떨어진다(확률 희석).</a:t>
             </a:r>
           </a:p>
         </p:txBody>
@@ -27756,7 +27756,7 @@
         </p:nvSpPr>
         <p:spPr>
           <a:xfrm>
-            <a:off x="6223000" y="2527498"/>
+            <a:off x="6223000" y="2748459"/>
             <a:ext cx="5257800" cy="1051520"/>
           </a:xfrm>
           <a:prstGeom prst="roundRect">
@@ -27787,7 +27787,7 @@
         </p:nvSpPr>
         <p:spPr>
           <a:xfrm>
-            <a:off x="6223000" y="2527498"/>
+            <a:off x="6223000" y="2748459"/>
             <a:ext cx="5257800" cy="6350"/>
           </a:xfrm>
           <a:prstGeom prst="rect">
@@ -27816,7 +27816,7 @@
         </p:nvSpPr>
         <p:spPr>
           <a:xfrm>
-            <a:off x="11474450" y="2527498"/>
+            <a:off x="11474450" y="2748459"/>
             <a:ext cx="6350" cy="1051520"/>
           </a:xfrm>
           <a:prstGeom prst="rect">
@@ -27845,7 +27845,7 @@
         </p:nvSpPr>
         <p:spPr>
           <a:xfrm>
-            <a:off x="6223000" y="3572669"/>
+            <a:off x="6223000" y="3793629"/>
             <a:ext cx="5257800" cy="6350"/>
           </a:xfrm>
           <a:prstGeom prst="rect">
@@ -27874,7 +27874,7 @@
         </p:nvSpPr>
         <p:spPr>
           <a:xfrm>
-            <a:off x="6223000" y="2527498"/>
+            <a:off x="6223000" y="2748459"/>
             <a:ext cx="50800" cy="1051520"/>
           </a:xfrm>
           <a:prstGeom prst="roundRect">
@@ -27905,7 +27905,7 @@
         </p:nvSpPr>
         <p:spPr>
           <a:xfrm>
-            <a:off x="6438900" y="2673548"/>
+            <a:off x="6438900" y="2894509"/>
             <a:ext cx="1439962" cy="241300"/>
           </a:xfrm>
           <a:prstGeom prst="roundRect">
@@ -27936,7 +27936,7 @@
         </p:nvSpPr>
         <p:spPr>
           <a:xfrm>
-            <a:off x="6527800" y="2698948"/>
+            <a:off x="6527800" y="2919909"/>
             <a:ext cx="1325427" cy="288925"/>
           </a:xfrm>
           <a:prstGeom prst="rect">
@@ -27977,7 +27977,7 @@
         </p:nvSpPr>
         <p:spPr>
           <a:xfrm>
-            <a:off x="6438900" y="2991048"/>
+            <a:off x="6438900" y="3212009"/>
             <a:ext cx="5041964" cy="603200"/>
           </a:xfrm>
           <a:prstGeom prst="rect">
@@ -28663,7 +28663,7 @@
                 <a:ea typeface="Malgun Gothic"/>
                 <a:cs typeface="Malgun Gothic"/>
               </a:rPr>
-              <a:t>soft-min은 늘 실제 최솟값보다 작아 안전한 상태까지 뺀다. 틈 지표가 ln 2보다 작으면 soft-min 실행 1,050번 중 통과 0번. 정확한 최솟값과 δ-활성 집합의 QP는 4,950번 위반 0, 대신 표본마다 QP를 푼다.</a:t>
+              <a:t>soft-min은 늘 실제 최솟값보다 작아 안전한 상태까지 뺀다. 틈 지표가 ln 2보다 작으면 soft-min 실행 1,050번 중 통과 0번. 정확한 최솟값과 δ-active set QP는 4,950번 위반 0, 대신 샘플마다 QP를 푼다.</a:t>
             </a:r>
           </a:p>
         </p:txBody>
@@ -29094,7 +29094,7 @@
                 <a:ea typeface="Malgun Gothic"/>
                 <a:cs typeface="Malgun Gothic"/>
               </a:rPr>
-              <a:t> 장애물이 칸 단위로 많을 때는 barrier를 하나씩 합치기보다 지도 전체에서 h 하나를 만드는 편이 틈을 지킨다.</a:t>
+              <a:t> 장애물이 셀 단위로 많을 때는 barrier를 하나씩 합치기보다 지도 전체에서 h 하나를 만드는 편이 틈을 지킨다.</a:t>
             </a:r>
           </a:p>
         </p:txBody>
@@ -29258,7 +29258,7 @@
                 <a:ea typeface="Malgun Gothic"/>
                 <a:cs typeface="Malgun Gothic"/>
               </a:rPr>
-              <a:t>5 · 표본 안전 필터</a:t>
+              <a:t>5 · 샘플 기반 안전 필터</a:t>
             </a:r>
           </a:p>
         </p:txBody>
@@ -29299,7 +29299,7 @@
                 <a:ea typeface="Malgun Gothic"/>
                 <a:cs typeface="Malgun Gothic"/>
               </a:rPr>
-              <a:t>안전한 표본이 하나도 없을 때만 백업 명령으로 개입한다</a:t>
+              <a:t>안전한 샘플이 하나도 없을 때만 백업 명령으로 개입한다</a:t>
             </a:r>
           </a:p>
         </p:txBody>
@@ -29342,7 +29342,7 @@
                 <a:ea typeface="Malgun Gothic"/>
                 <a:cs typeface="Malgun Gothic"/>
               </a:rPr>
-              <a:t>명목 명령을 한 스텝 적용했다고 보고, 그 뒤 명령열을 표본으로 뽑는다</a:t>
+              <a:t>명목 명령을 한 스텝 적용했다고 보고, 그 뒤 명령열을 샘플링한다</a:t>
             </a:r>
           </a:p>
         </p:txBody>
@@ -29385,7 +29385,7 @@
                 <a:ea typeface="Malgun Gothic"/>
                 <a:cs typeface="Malgun Gothic"/>
               </a:rPr>
-              <a:t>안전 = 지평 동안 위반 없음 + 끝 상태가 정지 가능한 불변 집합 안</a:t>
+              <a:t>안전 = horizon 동안 위반 없음 + 끝 상태가 정지 가능한 불변 집합 안</a:t>
             </a:r>
           </a:p>
         </p:txBody>
@@ -29428,7 +29428,7 @@
                 <a:ea typeface="Malgun Gothic"/>
                 <a:cs typeface="Malgun Gothic"/>
               </a:rPr>
-              <a:t>안전 표본이 없으면 저장한 백업 명령열의 첫 입력을 쓴다</a:t>
+              <a:t>안전 샘플이 없으면 저장한 백업 명령열의 첫 입력을 쓴다</a:t>
             </a:r>
           </a:p>
         </p:txBody>
@@ -29774,7 +29774,7 @@
                 <a:ea typeface="Malgun Gothic"/>
                 <a:cs typeface="Malgun Gothic"/>
               </a:rPr>
-              <a:t>해석적 모델 없이 표본으로 감시. 명목 제어기를 거의 건드리지 않는다.</a:t>
+              <a:t>해석적 모델 없이 샘플로 감시. 명목 제어기를 거의 건드리지 않는다.</a:t>
             </a:r>
           </a:p>
         </p:txBody>
@@ -29872,7 +29872,7 @@
                 <a:ea typeface="Malgun Gothic"/>
                 <a:cs typeface="Malgun Gothic"/>
               </a:rPr>
-              <a:t>표본 안전 필터 (Fig. 1): SV-MPC 필터(a)와 CEM 필터(b). CEM 쪽은 교착에 빠진다 — arXiv:2604.22149</a:t>
+              <a:t>샘플 기반 안전 필터 (Fig. 1): SV-MPC 필터(a)와 CEM 필터(b). CEM 쪽은 교착에 빠진다 — arXiv:2604.22149</a:t>
             </a:r>
           </a:p>
         </p:txBody>
@@ -29969,7 +29969,7 @@
                 <a:ea typeface="Malgun Gothic"/>
                 <a:cs typeface="Malgun Gothic"/>
               </a:rPr>
-              <a:t>표본 안전 필터, arXiv:2604.22149 (2026, 시뮬레이션)</a:t>
+              <a:t>샘플 기반 안전 필터, arXiv:2604.22149 (2026, 시뮬레이션)</a:t>
             </a:r>
           </a:p>
         </p:txBody>
@@ -31293,7 +31293,7 @@
                 <a:ea typeface="Malgun Gothic"/>
                 <a:cs typeface="Malgun Gothic"/>
               </a:rPr>
-              <a:t>제어기 가족을 한 표로 본다</a:t>
+              <a:t>제어기 계열을 한 표로 정리한다</a:t>
             </a:r>
           </a:p>
         </p:txBody>
@@ -31317,11 +31317,11 @@
                 <a:tableStyleId>{5C22544A-7EE6-4342-B048-85BDC9FD1C3A}</a:tableStyleId>
               </a:tblPr>
               <a:tblGrid>
-                <a:gridCol w="2696567"/>
-                <a:gridCol w="1181596"/>
-                <a:gridCol w="1571327"/>
-                <a:gridCol w="2551609"/>
-                <a:gridCol w="2768501"/>
+                <a:gridCol w="2626221"/>
+                <a:gridCol w="1150739"/>
+                <a:gridCol w="1530350"/>
+                <a:gridCol w="2765921"/>
+                <a:gridCol w="2696369"/>
               </a:tblGrid>
               <a:tr h="285477">
                 <a:tc>
@@ -31338,7 +31338,7 @@
                           <a:ea typeface="Malgun Gothic"/>
                           <a:cs typeface="Malgun Gothic"/>
                         </a:rPr>
-                        <a:t>가족</a:t>
+                        <a:t>계열</a:t>
                       </a:r>
                     </a:p>
                   </a:txBody>
@@ -31654,7 +31654,7 @@
                           <a:ea typeface="Malgun Gothic"/>
                           <a:cs typeface="Malgun Gothic"/>
                         </a:rPr>
-                        <a:t>튼튼한 경로 추종</a:t>
+                        <a:t>강건한 경로 추종</a:t>
                       </a:r>
                     </a:p>
                   </a:txBody>
@@ -32118,7 +32118,7 @@
                           <a:ea typeface="Malgun Gothic"/>
                           <a:cs typeface="Malgun Gothic"/>
                         </a:rPr>
-                        <a:t>벌점·확률</a:t>
+                        <a:t>페널티·확률</a:t>
                       </a:r>
                     </a:p>
                   </a:txBody>
@@ -32142,7 +32142,7 @@
                           <a:ea typeface="Malgun Gothic"/>
                           <a:cs typeface="Malgun Gothic"/>
                         </a:rPr>
-                        <a:t>비매끄러운 비용, GPU</a:t>
+                        <a:t>non-smooth 비용, GPU</a:t>
                       </a:r>
                     </a:p>
                   </a:txBody>
@@ -32166,7 +32166,7 @@
                           <a:ea typeface="Malgun Gothic"/>
                           <a:cs typeface="Malgun Gothic"/>
                         </a:rPr>
-                        <a:t>표본·온도 민감</a:t>
+                        <a:t>샘플 수·온도에 민감</a:t>
                       </a:r>
                     </a:p>
                   </a:txBody>
@@ -33074,7 +33074,7 @@
                 <a:ea typeface="Malgun Gothic"/>
                 <a:cs typeface="Malgun Gothic"/>
               </a:rPr>
-              <a:t>되먹임</a:t>
+              <a:t>피드백</a:t>
             </a:r>
           </a:p>
         </p:txBody>
@@ -33156,7 +33156,7 @@
                 <a:ea typeface="Malgun Gothic"/>
                 <a:cs typeface="Malgun Gothic"/>
               </a:rPr>
-              <a:t>모델이 틀려도, 외란이 와도 오차를 보고 바로잡는다. 열린 루프는 처음 계획만 믿는다.</a:t>
+              <a:t>모델이 틀려도, 외란이 와도 오차를 보고 바로잡는다. open loop는 처음 계획만 믿는다.</a:t>
             </a:r>
           </a:p>
         </p:txBody>
@@ -37070,7 +37070,7 @@
                 <a:ea typeface="Malgun Gothic"/>
                 <a:cs typeface="Malgun Gothic"/>
               </a:rPr>
-              <a:t>되먹임, PID, 안정성, 주파수 응답. 저자가 온라인에 공개했다.</a:t>
+              <a:t>피드백, PID, 안정성, 주파수 응답. 저자가 온라인에 공개했다.</a:t>
             </a:r>
           </a:p>
         </p:txBody>
@@ -37536,7 +37536,7 @@
         <p:spPr>
           <a:xfrm>
             <a:off x="8208367" y="1507728"/>
-            <a:ext cx="698302" cy="241300"/>
+            <a:ext cx="584994" cy="241300"/>
           </a:xfrm>
           <a:prstGeom prst="roundRect">
             <a:avLst>
@@ -37567,7 +37567,7 @@
         <p:spPr>
           <a:xfrm>
             <a:off x="8297267" y="1533128"/>
-            <a:ext cx="561517" cy="288925"/>
+            <a:ext cx="444810" cy="288925"/>
           </a:xfrm>
           <a:prstGeom prst="rect">
             <a:avLst/>
@@ -37594,7 +37594,7 @@
                 <a:ea typeface="Malgun Gothic"/>
                 <a:cs typeface="Malgun Gothic"/>
               </a:rPr>
-              <a:t>3 · 손으로</a:t>
+              <a:t>3 · 실습</a:t>
             </a:r>
           </a:p>
         </p:txBody>
@@ -37842,7 +37842,7 @@
                           <a:ea typeface="Malgun Gothic"/>
                           <a:cs typeface="Malgun Gothic"/>
                         </a:rPr>
-                        <a:t>이동 지평은 왜 모델 오차에 되먹임이 되나?</a:t>
+                        <a:t>receding horizon은 왜 모델 오차에 대한 피드백이 되나?</a:t>
                       </a:r>
                     </a:p>
                   </a:txBody>
@@ -38110,7 +38110,7 @@
                 <a:ea typeface="Malgun Gothic"/>
                 <a:cs typeface="Malgun Gothic"/>
               </a:rPr>
-              <a:t>제어는 미래를 예측하고, 되먹임으로 고치고, 안전은 따로 지킨다</a:t>
+              <a:t>제어는 미래를 예측하고, 피드백으로 고치고, 안전은 따로 지킨다</a:t>
             </a:r>
           </a:p>
         </p:txBody>
@@ -38300,7 +38300,7 @@
                 <a:ea typeface="Malgun Gothic"/>
                 <a:cs typeface="Malgun Gothic"/>
               </a:rPr>
-              <a:t>되먹임</a:t>
+              <a:t>피드백</a:t>
             </a:r>
           </a:p>
         </p:txBody>
@@ -38762,7 +38762,7 @@
                 <a:ea typeface="Malgun Gothic"/>
                 <a:cs typeface="Malgun Gothic"/>
               </a:rPr>
-              <a:t>표본 기반</a:t>
+              <a:t>샘플 기반</a:t>
             </a:r>
           </a:p>
         </p:txBody>
@@ -38803,7 +38803,7 @@
                 <a:ea typeface="Malgun Gothic"/>
                 <a:cs typeface="Malgun Gothic"/>
               </a:rPr>
-              <a:t>MPPI는 미분 없이 비매끄러운 비용을. 온도·잡음이 손잡이.</a:t>
+              <a:t>MPPI는 미분 없이 non-smooth 비용을 다룬다. 온도·잡음이 튜닝 파라미터다.</a:t>
             </a:r>
           </a:p>
         </p:txBody>
@@ -39034,7 +39034,7 @@
                 <a:ea typeface="Malgun Gothic"/>
                 <a:cs typeface="Malgun Gothic"/>
               </a:rPr>
-              <a:t>지연을 먼저 넣고, 남는 몫은 작은 잔차로, σ와 함께.</a:t>
+              <a:t>지연을 먼저 넣고, 남는 부분은 작은 잔차로, σ와 함께.</a:t>
             </a:r>
           </a:p>
         </p:txBody>
@@ -39769,7 +39769,7 @@
                           <a:ea typeface="Malgun Gothic"/>
                           <a:cs typeface="Malgun Gothic"/>
                         </a:rPr>
-                        <a:t>되먹임, 안정성, PID의 직관</a:t>
+                        <a:t>피드백, 안정성, PID의 직관</a:t>
                       </a:r>
                     </a:p>
                   </a:txBody>
@@ -39991,7 +39991,7 @@
                           <a:ea typeface="Malgun Gothic"/>
                           <a:cs typeface="Malgun Gothic"/>
                         </a:rPr>
-                        <a:t>표본 기반 MPC의 식과 유도</a:t>
+                        <a:t>샘플 기반 MPC의 식과 유도</a:t>
                       </a:r>
                     </a:p>
                   </a:txBody>
@@ -40405,7 +40405,7 @@
         <p:spPr>
           <a:xfrm>
             <a:off x="6172200" y="1361678"/>
-            <a:ext cx="5493258" cy="979488"/>
+            <a:ext cx="5493258" cy="1289050"/>
           </a:xfrm>
           <a:prstGeom prst="rect">
             <a:avLst/>
@@ -40443,7 +40443,7 @@
                 <a:ea typeface="Malgun Gothic"/>
                 <a:cs typeface="Malgun Gothic"/>
               </a:rPr>
-              <a:t> — PETS 1805.12114 · IKD 2102.12667 · RMA 2107.04034 · TD-MPC2 2310.16828 · 지형 인지 운동 모델 2305.00676 · HDVIO2.0 2504.00969 · Continual VND 2606.27353 · OptCar 2607.13319</a:t>
+              <a:t> — PETS 1805.12114 · IKD 2102.12667 · RMA 2107.04034 · TD-MPC2 2310.16828 · 지형 인지 kinodynamic 모델 2305.00676 · HDVIO2.0 2504.00969 · Continual VND 2606.27353 · OptCar 2607.13319</a:t>
             </a:r>
           </a:p>
         </p:txBody>
@@ -40456,7 +40456,7 @@
         </p:nvSpPr>
         <p:spPr>
           <a:xfrm>
-            <a:off x="6172200" y="2218928"/>
+            <a:off x="6172200" y="2466578"/>
             <a:ext cx="5493258" cy="669925"/>
           </a:xfrm>
           <a:prstGeom prst="rect">
@@ -40508,7 +40508,7 @@
         </p:nvSpPr>
         <p:spPr>
           <a:xfrm>
-            <a:off x="6172200" y="2828528"/>
+            <a:off x="6172200" y="3076178"/>
             <a:ext cx="5493258" cy="1289050"/>
           </a:xfrm>
           <a:prstGeom prst="rect">
@@ -40547,7 +40547,7 @@
                 <a:ea typeface="Malgun Gothic"/>
                 <a:cs typeface="Malgun Gothic"/>
               </a:rPr>
-              <a:t> — CBF 개관 1903.11199 · RA-MPPI 2209.12842 · DRA-MPPI 2506.21205 · DUCCT-MPPI 2605.28330 · 접촉 최댓값 전파 2610.06103 · Poisson 안전 함수 2505.06794 · Exact-Safe MPPI 2610.07369 · 표본 안전 필터 2604.22149</a:t>
+              <a:t> — CBF 개관 1903.11199 · RA-MPPI 2209.12842 · DRA-MPPI 2506.21205 · DUCCT-MPPI 2605.28330 · 접촉 최댓값 전파 2610.06103 · Poisson 안전 함수 2505.06794 · Exact-Safe MPPI 2610.07369 · 샘플 기반 안전 필터 2604.22149</a:t>
             </a:r>
           </a:p>
         </p:txBody>
@@ -40614,7 +40614,7 @@
                 <a:ea typeface="Malgun Gothic"/>
                 <a:cs typeface="Malgun Gothic"/>
               </a:rPr>
-              <a:t>0 · 되먹임 고리</a:t>
+              <a:t>0 · 피드백 루프</a:t>
             </a:r>
           </a:p>
         </p:txBody>
@@ -40753,7 +40753,7 @@
                 <a:ea typeface="Malgun Gothic"/>
                 <a:cs typeface="Malgun Gothic"/>
               </a:rPr>
-              <a:t>되먹임 제어 고리. 로봇(plant)에는 지연·슬립·한계가 있고, 외란이 들어오고, 상태는 센서로 다시 잰다</a:t>
+              <a:t>피드백 제어 루프. 로봇(plant)에는 지연·슬립·한계가 있고, 외란이 들어오고, 상태는 센서로 다시 잰다</a:t>
             </a:r>
           </a:p>
         </p:txBody>
@@ -42757,7 +42757,7 @@
         <p:spPr>
           <a:xfrm>
             <a:off x="8208367" y="5631061"/>
-            <a:ext cx="3219310" cy="327000"/>
+            <a:ext cx="3219310" cy="603200"/>
           </a:xfrm>
           <a:prstGeom prst="rect">
             <a:avLst/>
@@ -42784,7 +42784,7 @@
                 <a:ea typeface="Malgun Gothic"/>
                 <a:cs typeface="Malgun Gothic"/>
               </a:rPr>
-              <a:t>제동을 건다. 잡음을 키우므로 걸러서 쓴다.</a:t>
+              <a:t>감쇠(damping)를 준다. 잡음을 키우므로 필터를 거쳐 쓴다.</a:t>
             </a:r>
           </a:p>
         </p:txBody>
@@ -43252,7 +43252,7 @@
                 <a:ea typeface="Malgun Gothic"/>
                 <a:cs typeface="Malgun Gothic"/>
               </a:rPr>
-              <a:t>식 한 줄, 튜닝 손잡이 하나(L_d). 차·바퀴 로봇에서 튼튼하다. 속도에 비례해 L_d를 키우면 고속에서도 안정적이다.</a:t>
+              <a:t>식 한 줄, 튜닝 파라미터 하나(L_d). 차·바퀴 로봇에서 강건하다. 속도에 비례해 L_d를 키우면 고속에서도 안정적이다.</a:t>
             </a:r>
           </a:p>
         </p:txBody>
@@ -43719,7 +43719,7 @@
                 <a:ea typeface="Malgun Gothic"/>
                 <a:cs typeface="Malgun Gothic"/>
               </a:rPr>
-              <a:t>고전 추종기는 단순하고 튼튼하지만 제약과 미래를 모른다</a:t>
+              <a:t>고전 추종기는 단순하고 강건하지만 제약과 미래를 모른다</a:t>
             </a:r>
           </a:p>
         </p:txBody>
@@ -44007,7 +44007,7 @@
                           <a:ea typeface="Malgun Gothic"/>
                           <a:cs typeface="Malgun Gothic"/>
                         </a:rPr>
-                        <a:t>기하만으로, 튼튼</a:t>
+                        <a:t>기하만으로, 강건</a:t>
                       </a:r>
                     </a:p>
                   </a:txBody>

</xml_diff>